<commit_message>
Add Korean company names next to tickers and improve table readability
Co-authored-by: Cursor <cursoragent@cursor.com>
</commit_message>
<xml_diff>
--- a/reports/megatrend-investment-report-2026.pptx
+++ b/reports/megatrend-investment-report-2026.pptx
@@ -6330,7 +6330,7 @@
         </p:nvGraphicFramePr>
         <p:xfrm>
           <a:off x="365760" y="1691640"/>
-          <a:ext cx="6446520" cy="2816352"/>
+          <a:ext cx="6446520" cy="3191256"/>
         </p:xfrm>
         <a:graphic>
           <a:graphicData uri="http://schemas.openxmlformats.org/drawingml/2006/table">
@@ -6345,14 +6345,14 @@
                 <a:gridCol w="1463040"/>
                 <a:gridCol w="1371600"/>
               </a:tblGrid>
-              <a:tr h="312928">
+              <a:tr h="354584">
                 <a:tc>
                   <a:txBody>
                     <a:bodyPr/>
                     <a:lstStyle/>
                     <a:p>
                       <a:pPr>
-                        <a:defRPr b="1" sz="900">
+                        <a:defRPr b="1" sz="1100">
                           <a:solidFill>
                             <a:srgbClr val="FFFFFF"/>
                           </a:solidFill>
@@ -6375,7 +6375,7 @@
                     <a:lstStyle/>
                     <a:p>
                       <a:pPr>
-                        <a:defRPr b="1" sz="900">
+                        <a:defRPr b="1" sz="1100">
                           <a:solidFill>
                             <a:srgbClr val="FFFFFF"/>
                           </a:solidFill>
@@ -6398,7 +6398,7 @@
                     <a:lstStyle/>
                     <a:p>
                       <a:pPr>
-                        <a:defRPr b="1" sz="900">
+                        <a:defRPr b="1" sz="1100">
                           <a:solidFill>
                             <a:srgbClr val="FFFFFF"/>
                           </a:solidFill>
@@ -6421,7 +6421,7 @@
                     <a:lstStyle/>
                     <a:p>
                       <a:pPr>
-                        <a:defRPr b="1" sz="900">
+                        <a:defRPr b="1" sz="1100">
                           <a:solidFill>
                             <a:srgbClr val="FFFFFF"/>
                           </a:solidFill>
@@ -6444,7 +6444,7 @@
                     <a:lstStyle/>
                     <a:p>
                       <a:pPr>
-                        <a:defRPr b="1" sz="900">
+                        <a:defRPr b="1" sz="1100">
                           <a:solidFill>
                             <a:srgbClr val="FFFFFF"/>
                           </a:solidFill>
@@ -6462,14 +6462,14 @@
                   </a:tcPr>
                 </a:tc>
               </a:tr>
-              <a:tr h="312928">
+              <a:tr h="354584">
                 <a:tc>
                   <a:txBody>
                     <a:bodyPr/>
                     <a:lstStyle/>
                     <a:p>
                       <a:pPr>
-                        <a:defRPr sz="800">
+                        <a:defRPr sz="1000">
                           <a:solidFill>
                             <a:srgbClr val="334155"/>
                           </a:solidFill>
@@ -6480,7 +6480,7 @@
                       </a:r>
                     </a:p>
                   </a:txBody>
-                  <a:tcPr>
+                  <a:tcPr marL="54864" marR="36576" marT="36576" marB="36576">
                     <a:solidFill>
                       <a:srgbClr val="F8FAFC"/>
                     </a:solidFill>
@@ -6492,7 +6492,7 @@
                     <a:lstStyle/>
                     <a:p>
                       <a:pPr>
-                        <a:defRPr sz="800">
+                        <a:defRPr sz="1000">
                           <a:solidFill>
                             <a:srgbClr val="334155"/>
                           </a:solidFill>
@@ -6503,7 +6503,7 @@
                       </a:r>
                     </a:p>
                   </a:txBody>
-                  <a:tcPr>
+                  <a:tcPr marL="54864" marR="36576" marT="36576" marB="36576">
                     <a:solidFill>
                       <a:srgbClr val="F8FAFC"/>
                     </a:solidFill>
@@ -6515,7 +6515,7 @@
                     <a:lstStyle/>
                     <a:p>
                       <a:pPr>
-                        <a:defRPr sz="800">
+                        <a:defRPr sz="1000">
                           <a:solidFill>
                             <a:srgbClr val="334155"/>
                           </a:solidFill>
@@ -6526,7 +6526,7 @@
                       </a:r>
                     </a:p>
                   </a:txBody>
-                  <a:tcPr>
+                  <a:tcPr marL="54864" marR="36576" marT="36576" marB="36576">
                     <a:solidFill>
                       <a:srgbClr val="F8FAFC"/>
                     </a:solidFill>
@@ -6538,7 +6538,7 @@
                     <a:lstStyle/>
                     <a:p>
                       <a:pPr>
-                        <a:defRPr sz="800">
+                        <a:defRPr sz="1000">
                           <a:solidFill>
                             <a:srgbClr val="334155"/>
                           </a:solidFill>
@@ -6549,7 +6549,7 @@
                       </a:r>
                     </a:p>
                   </a:txBody>
-                  <a:tcPr>
+                  <a:tcPr marL="54864" marR="36576" marT="36576" marB="36576">
                     <a:solidFill>
                       <a:srgbClr val="F8FAFC"/>
                     </a:solidFill>
@@ -6561,7 +6561,7 @@
                     <a:lstStyle/>
                     <a:p>
                       <a:pPr>
-                        <a:defRPr sz="800">
+                        <a:defRPr sz="1000">
                           <a:solidFill>
                             <a:srgbClr val="334155"/>
                           </a:solidFill>
@@ -6572,21 +6572,21 @@
                       </a:r>
                     </a:p>
                   </a:txBody>
-                  <a:tcPr>
+                  <a:tcPr marL="54864" marR="36576" marT="36576" marB="36576">
                     <a:solidFill>
                       <a:srgbClr val="F8FAFC"/>
                     </a:solidFill>
                   </a:tcPr>
                 </a:tc>
               </a:tr>
-              <a:tr h="312928">
+              <a:tr h="354584">
                 <a:tc>
                   <a:txBody>
                     <a:bodyPr/>
                     <a:lstStyle/>
                     <a:p>
                       <a:pPr>
-                        <a:defRPr sz="800">
+                        <a:defRPr sz="1000">
                           <a:solidFill>
                             <a:srgbClr val="334155"/>
                           </a:solidFill>
@@ -6597,7 +6597,7 @@
                       </a:r>
                     </a:p>
                   </a:txBody>
-                  <a:tcPr>
+                  <a:tcPr marL="54864" marR="36576" marT="36576" marB="36576">
                     <a:solidFill>
                       <a:srgbClr val="FFFFFF"/>
                     </a:solidFill>
@@ -6609,7 +6609,7 @@
                     <a:lstStyle/>
                     <a:p>
                       <a:pPr>
-                        <a:defRPr sz="800">
+                        <a:defRPr sz="1000">
                           <a:solidFill>
                             <a:srgbClr val="334155"/>
                           </a:solidFill>
@@ -6620,7 +6620,7 @@
                       </a:r>
                     </a:p>
                   </a:txBody>
-                  <a:tcPr>
+                  <a:tcPr marL="54864" marR="36576" marT="36576" marB="36576">
                     <a:solidFill>
                       <a:srgbClr val="FFFFFF"/>
                     </a:solidFill>
@@ -6632,7 +6632,7 @@
                     <a:lstStyle/>
                     <a:p>
                       <a:pPr>
-                        <a:defRPr sz="800">
+                        <a:defRPr sz="1000">
                           <a:solidFill>
                             <a:srgbClr val="334155"/>
                           </a:solidFill>
@@ -6643,7 +6643,7 @@
                       </a:r>
                     </a:p>
                   </a:txBody>
-                  <a:tcPr>
+                  <a:tcPr marL="54864" marR="36576" marT="36576" marB="36576">
                     <a:solidFill>
                       <a:srgbClr val="FFFFFF"/>
                     </a:solidFill>
@@ -6655,7 +6655,7 @@
                     <a:lstStyle/>
                     <a:p>
                       <a:pPr>
-                        <a:defRPr sz="800">
+                        <a:defRPr sz="1000">
                           <a:solidFill>
                             <a:srgbClr val="334155"/>
                           </a:solidFill>
@@ -6666,7 +6666,7 @@
                       </a:r>
                     </a:p>
                   </a:txBody>
-                  <a:tcPr>
+                  <a:tcPr marL="54864" marR="36576" marT="36576" marB="36576">
                     <a:solidFill>
                       <a:srgbClr val="FFFFFF"/>
                     </a:solidFill>
@@ -6678,7 +6678,7 @@
                     <a:lstStyle/>
                     <a:p>
                       <a:pPr>
-                        <a:defRPr sz="800">
+                        <a:defRPr sz="1000">
                           <a:solidFill>
                             <a:srgbClr val="334155"/>
                           </a:solidFill>
@@ -6689,21 +6689,21 @@
                       </a:r>
                     </a:p>
                   </a:txBody>
-                  <a:tcPr>
+                  <a:tcPr marL="54864" marR="36576" marT="36576" marB="36576">
                     <a:solidFill>
                       <a:srgbClr val="FFFFFF"/>
                     </a:solidFill>
                   </a:tcPr>
                 </a:tc>
               </a:tr>
-              <a:tr h="312928">
+              <a:tr h="354584">
                 <a:tc>
                   <a:txBody>
                     <a:bodyPr/>
                     <a:lstStyle/>
                     <a:p>
                       <a:pPr>
-                        <a:defRPr sz="800">
+                        <a:defRPr sz="1000">
                           <a:solidFill>
                             <a:srgbClr val="334155"/>
                           </a:solidFill>
@@ -6714,7 +6714,7 @@
                       </a:r>
                     </a:p>
                   </a:txBody>
-                  <a:tcPr>
+                  <a:tcPr marL="54864" marR="36576" marT="36576" marB="36576">
                     <a:solidFill>
                       <a:srgbClr val="F8FAFC"/>
                     </a:solidFill>
@@ -6726,7 +6726,7 @@
                     <a:lstStyle/>
                     <a:p>
                       <a:pPr>
-                        <a:defRPr sz="800">
+                        <a:defRPr sz="1000">
                           <a:solidFill>
                             <a:srgbClr val="334155"/>
                           </a:solidFill>
@@ -6737,7 +6737,7 @@
                       </a:r>
                     </a:p>
                   </a:txBody>
-                  <a:tcPr>
+                  <a:tcPr marL="54864" marR="36576" marT="36576" marB="36576">
                     <a:solidFill>
                       <a:srgbClr val="F8FAFC"/>
                     </a:solidFill>
@@ -6749,7 +6749,7 @@
                     <a:lstStyle/>
                     <a:p>
                       <a:pPr>
-                        <a:defRPr sz="800">
+                        <a:defRPr sz="1000">
                           <a:solidFill>
                             <a:srgbClr val="334155"/>
                           </a:solidFill>
@@ -6760,7 +6760,7 @@
                       </a:r>
                     </a:p>
                   </a:txBody>
-                  <a:tcPr>
+                  <a:tcPr marL="54864" marR="36576" marT="36576" marB="36576">
                     <a:solidFill>
                       <a:srgbClr val="F8FAFC"/>
                     </a:solidFill>
@@ -6772,7 +6772,7 @@
                     <a:lstStyle/>
                     <a:p>
                       <a:pPr>
-                        <a:defRPr sz="800">
+                        <a:defRPr sz="1000">
                           <a:solidFill>
                             <a:srgbClr val="334155"/>
                           </a:solidFill>
@@ -6783,7 +6783,7 @@
                       </a:r>
                     </a:p>
                   </a:txBody>
-                  <a:tcPr>
+                  <a:tcPr marL="54864" marR="36576" marT="36576" marB="36576">
                     <a:solidFill>
                       <a:srgbClr val="F8FAFC"/>
                     </a:solidFill>
@@ -6795,7 +6795,7 @@
                     <a:lstStyle/>
                     <a:p>
                       <a:pPr>
-                        <a:defRPr sz="800">
+                        <a:defRPr sz="1000">
                           <a:solidFill>
                             <a:srgbClr val="334155"/>
                           </a:solidFill>
@@ -6806,21 +6806,21 @@
                       </a:r>
                     </a:p>
                   </a:txBody>
-                  <a:tcPr>
+                  <a:tcPr marL="54864" marR="36576" marT="36576" marB="36576">
                     <a:solidFill>
                       <a:srgbClr val="F8FAFC"/>
                     </a:solidFill>
                   </a:tcPr>
                 </a:tc>
               </a:tr>
-              <a:tr h="312928">
+              <a:tr h="354584">
                 <a:tc>
                   <a:txBody>
                     <a:bodyPr/>
                     <a:lstStyle/>
                     <a:p>
                       <a:pPr>
-                        <a:defRPr sz="800">
+                        <a:defRPr sz="1000">
                           <a:solidFill>
                             <a:srgbClr val="334155"/>
                           </a:solidFill>
@@ -6831,7 +6831,7 @@
                       </a:r>
                     </a:p>
                   </a:txBody>
-                  <a:tcPr>
+                  <a:tcPr marL="54864" marR="36576" marT="36576" marB="36576">
                     <a:solidFill>
                       <a:srgbClr val="FFFFFF"/>
                     </a:solidFill>
@@ -6843,7 +6843,7 @@
                     <a:lstStyle/>
                     <a:p>
                       <a:pPr>
-                        <a:defRPr sz="800">
+                        <a:defRPr sz="1000">
                           <a:solidFill>
                             <a:srgbClr val="334155"/>
                           </a:solidFill>
@@ -6854,7 +6854,7 @@
                       </a:r>
                     </a:p>
                   </a:txBody>
-                  <a:tcPr>
+                  <a:tcPr marL="54864" marR="36576" marT="36576" marB="36576">
                     <a:solidFill>
                       <a:srgbClr val="FFFFFF"/>
                     </a:solidFill>
@@ -6866,7 +6866,7 @@
                     <a:lstStyle/>
                     <a:p>
                       <a:pPr>
-                        <a:defRPr sz="800">
+                        <a:defRPr sz="1000">
                           <a:solidFill>
                             <a:srgbClr val="334155"/>
                           </a:solidFill>
@@ -6877,7 +6877,7 @@
                       </a:r>
                     </a:p>
                   </a:txBody>
-                  <a:tcPr>
+                  <a:tcPr marL="54864" marR="36576" marT="36576" marB="36576">
                     <a:solidFill>
                       <a:srgbClr val="FFFFFF"/>
                     </a:solidFill>
@@ -6889,7 +6889,7 @@
                     <a:lstStyle/>
                     <a:p>
                       <a:pPr>
-                        <a:defRPr sz="800">
+                        <a:defRPr sz="1000">
                           <a:solidFill>
                             <a:srgbClr val="334155"/>
                           </a:solidFill>
@@ -6900,7 +6900,7 @@
                       </a:r>
                     </a:p>
                   </a:txBody>
-                  <a:tcPr>
+                  <a:tcPr marL="54864" marR="36576" marT="36576" marB="36576">
                     <a:solidFill>
                       <a:srgbClr val="FFFFFF"/>
                     </a:solidFill>
@@ -6912,7 +6912,7 @@
                     <a:lstStyle/>
                     <a:p>
                       <a:pPr>
-                        <a:defRPr sz="800">
+                        <a:defRPr sz="1000">
                           <a:solidFill>
                             <a:srgbClr val="334155"/>
                           </a:solidFill>
@@ -6923,21 +6923,21 @@
                       </a:r>
                     </a:p>
                   </a:txBody>
-                  <a:tcPr>
+                  <a:tcPr marL="54864" marR="36576" marT="36576" marB="36576">
                     <a:solidFill>
                       <a:srgbClr val="FFFFFF"/>
                     </a:solidFill>
                   </a:tcPr>
                 </a:tc>
               </a:tr>
-              <a:tr h="312928">
+              <a:tr h="354584">
                 <a:tc>
                   <a:txBody>
                     <a:bodyPr/>
                     <a:lstStyle/>
                     <a:p>
                       <a:pPr>
-                        <a:defRPr sz="800">
+                        <a:defRPr sz="1000">
                           <a:solidFill>
                             <a:srgbClr val="334155"/>
                           </a:solidFill>
@@ -6948,7 +6948,7 @@
                       </a:r>
                     </a:p>
                   </a:txBody>
-                  <a:tcPr>
+                  <a:tcPr marL="54864" marR="36576" marT="36576" marB="36576">
                     <a:solidFill>
                       <a:srgbClr val="F8FAFC"/>
                     </a:solidFill>
@@ -6960,7 +6960,7 @@
                     <a:lstStyle/>
                     <a:p>
                       <a:pPr>
-                        <a:defRPr sz="800">
+                        <a:defRPr sz="1000">
                           <a:solidFill>
                             <a:srgbClr val="334155"/>
                           </a:solidFill>
@@ -6971,7 +6971,7 @@
                       </a:r>
                     </a:p>
                   </a:txBody>
-                  <a:tcPr>
+                  <a:tcPr marL="54864" marR="36576" marT="36576" marB="36576">
                     <a:solidFill>
                       <a:srgbClr val="F8FAFC"/>
                     </a:solidFill>
@@ -6983,7 +6983,7 @@
                     <a:lstStyle/>
                     <a:p>
                       <a:pPr>
-                        <a:defRPr sz="800">
+                        <a:defRPr sz="1000">
                           <a:solidFill>
                             <a:srgbClr val="334155"/>
                           </a:solidFill>
@@ -6994,7 +6994,7 @@
                       </a:r>
                     </a:p>
                   </a:txBody>
-                  <a:tcPr>
+                  <a:tcPr marL="54864" marR="36576" marT="36576" marB="36576">
                     <a:solidFill>
                       <a:srgbClr val="F8FAFC"/>
                     </a:solidFill>
@@ -7006,7 +7006,7 @@
                     <a:lstStyle/>
                     <a:p>
                       <a:pPr>
-                        <a:defRPr sz="800">
+                        <a:defRPr sz="1000">
                           <a:solidFill>
                             <a:srgbClr val="334155"/>
                           </a:solidFill>
@@ -7017,7 +7017,7 @@
                       </a:r>
                     </a:p>
                   </a:txBody>
-                  <a:tcPr>
+                  <a:tcPr marL="54864" marR="36576" marT="36576" marB="36576">
                     <a:solidFill>
                       <a:srgbClr val="F8FAFC"/>
                     </a:solidFill>
@@ -7029,7 +7029,7 @@
                     <a:lstStyle/>
                     <a:p>
                       <a:pPr>
-                        <a:defRPr sz="800">
+                        <a:defRPr sz="1000">
                           <a:solidFill>
                             <a:srgbClr val="334155"/>
                           </a:solidFill>
@@ -7040,21 +7040,21 @@
                       </a:r>
                     </a:p>
                   </a:txBody>
-                  <a:tcPr>
+                  <a:tcPr marL="54864" marR="36576" marT="36576" marB="36576">
                     <a:solidFill>
                       <a:srgbClr val="F8FAFC"/>
                     </a:solidFill>
                   </a:tcPr>
                 </a:tc>
               </a:tr>
-              <a:tr h="312928">
+              <a:tr h="354584">
                 <a:tc>
                   <a:txBody>
                     <a:bodyPr/>
                     <a:lstStyle/>
                     <a:p>
                       <a:pPr>
-                        <a:defRPr sz="800">
+                        <a:defRPr sz="1000">
                           <a:solidFill>
                             <a:srgbClr val="334155"/>
                           </a:solidFill>
@@ -7065,7 +7065,7 @@
                       </a:r>
                     </a:p>
                   </a:txBody>
-                  <a:tcPr>
+                  <a:tcPr marL="54864" marR="36576" marT="36576" marB="36576">
                     <a:solidFill>
                       <a:srgbClr val="FFFFFF"/>
                     </a:solidFill>
@@ -7077,7 +7077,7 @@
                     <a:lstStyle/>
                     <a:p>
                       <a:pPr>
-                        <a:defRPr sz="800">
+                        <a:defRPr sz="1000">
                           <a:solidFill>
                             <a:srgbClr val="334155"/>
                           </a:solidFill>
@@ -7088,7 +7088,7 @@
                       </a:r>
                     </a:p>
                   </a:txBody>
-                  <a:tcPr>
+                  <a:tcPr marL="54864" marR="36576" marT="36576" marB="36576">
                     <a:solidFill>
                       <a:srgbClr val="FFFFFF"/>
                     </a:solidFill>
@@ -7100,7 +7100,7 @@
                     <a:lstStyle/>
                     <a:p>
                       <a:pPr>
-                        <a:defRPr sz="800">
+                        <a:defRPr sz="1000">
                           <a:solidFill>
                             <a:srgbClr val="334155"/>
                           </a:solidFill>
@@ -7111,7 +7111,7 @@
                       </a:r>
                     </a:p>
                   </a:txBody>
-                  <a:tcPr>
+                  <a:tcPr marL="54864" marR="36576" marT="36576" marB="36576">
                     <a:solidFill>
                       <a:srgbClr val="FFFFFF"/>
                     </a:solidFill>
@@ -7123,7 +7123,7 @@
                     <a:lstStyle/>
                     <a:p>
                       <a:pPr>
-                        <a:defRPr sz="800">
+                        <a:defRPr sz="1000">
                           <a:solidFill>
                             <a:srgbClr val="334155"/>
                           </a:solidFill>
@@ -7134,7 +7134,7 @@
                       </a:r>
                     </a:p>
                   </a:txBody>
-                  <a:tcPr>
+                  <a:tcPr marL="54864" marR="36576" marT="36576" marB="36576">
                     <a:solidFill>
                       <a:srgbClr val="FFFFFF"/>
                     </a:solidFill>
@@ -7146,7 +7146,7 @@
                     <a:lstStyle/>
                     <a:p>
                       <a:pPr>
-                        <a:defRPr sz="800">
+                        <a:defRPr sz="1000">
                           <a:solidFill>
                             <a:srgbClr val="334155"/>
                           </a:solidFill>
@@ -7157,21 +7157,21 @@
                       </a:r>
                     </a:p>
                   </a:txBody>
-                  <a:tcPr>
+                  <a:tcPr marL="54864" marR="36576" marT="36576" marB="36576">
                     <a:solidFill>
                       <a:srgbClr val="FFFFFF"/>
                     </a:solidFill>
                   </a:tcPr>
                 </a:tc>
               </a:tr>
-              <a:tr h="312928">
+              <a:tr h="354584">
                 <a:tc>
                   <a:txBody>
                     <a:bodyPr/>
                     <a:lstStyle/>
                     <a:p>
                       <a:pPr>
-                        <a:defRPr sz="800">
+                        <a:defRPr sz="1000">
                           <a:solidFill>
                             <a:srgbClr val="334155"/>
                           </a:solidFill>
@@ -7182,7 +7182,7 @@
                       </a:r>
                     </a:p>
                   </a:txBody>
-                  <a:tcPr>
+                  <a:tcPr marL="54864" marR="36576" marT="36576" marB="36576">
                     <a:solidFill>
                       <a:srgbClr val="F8FAFC"/>
                     </a:solidFill>
@@ -7194,7 +7194,7 @@
                     <a:lstStyle/>
                     <a:p>
                       <a:pPr>
-                        <a:defRPr sz="800">
+                        <a:defRPr sz="1000">
                           <a:solidFill>
                             <a:srgbClr val="334155"/>
                           </a:solidFill>
@@ -7205,7 +7205,7 @@
                       </a:r>
                     </a:p>
                   </a:txBody>
-                  <a:tcPr>
+                  <a:tcPr marL="54864" marR="36576" marT="36576" marB="36576">
                     <a:solidFill>
                       <a:srgbClr val="F8FAFC"/>
                     </a:solidFill>
@@ -7217,7 +7217,7 @@
                     <a:lstStyle/>
                     <a:p>
                       <a:pPr>
-                        <a:defRPr sz="800">
+                        <a:defRPr sz="1000">
                           <a:solidFill>
                             <a:srgbClr val="334155"/>
                           </a:solidFill>
@@ -7228,7 +7228,7 @@
                       </a:r>
                     </a:p>
                   </a:txBody>
-                  <a:tcPr>
+                  <a:tcPr marL="54864" marR="36576" marT="36576" marB="36576">
                     <a:solidFill>
                       <a:srgbClr val="F8FAFC"/>
                     </a:solidFill>
@@ -7240,7 +7240,7 @@
                     <a:lstStyle/>
                     <a:p>
                       <a:pPr>
-                        <a:defRPr sz="800">
+                        <a:defRPr sz="1000">
                           <a:solidFill>
                             <a:srgbClr val="334155"/>
                           </a:solidFill>
@@ -7251,7 +7251,7 @@
                       </a:r>
                     </a:p>
                   </a:txBody>
-                  <a:tcPr>
+                  <a:tcPr marL="54864" marR="36576" marT="36576" marB="36576">
                     <a:solidFill>
                       <a:srgbClr val="F8FAFC"/>
                     </a:solidFill>
@@ -7263,7 +7263,7 @@
                     <a:lstStyle/>
                     <a:p>
                       <a:pPr>
-                        <a:defRPr sz="800">
+                        <a:defRPr sz="1000">
                           <a:solidFill>
                             <a:srgbClr val="334155"/>
                           </a:solidFill>
@@ -7274,21 +7274,21 @@
                       </a:r>
                     </a:p>
                   </a:txBody>
-                  <a:tcPr>
+                  <a:tcPr marL="54864" marR="36576" marT="36576" marB="36576">
                     <a:solidFill>
                       <a:srgbClr val="F8FAFC"/>
                     </a:solidFill>
                   </a:tcPr>
                 </a:tc>
               </a:tr>
-              <a:tr h="312928">
+              <a:tr h="354584">
                 <a:tc>
                   <a:txBody>
                     <a:bodyPr/>
                     <a:lstStyle/>
                     <a:p>
                       <a:pPr>
-                        <a:defRPr sz="800">
+                        <a:defRPr sz="1000">
                           <a:solidFill>
                             <a:srgbClr val="334155"/>
                           </a:solidFill>
@@ -7299,7 +7299,7 @@
                       </a:r>
                     </a:p>
                   </a:txBody>
-                  <a:tcPr>
+                  <a:tcPr marL="54864" marR="36576" marT="36576" marB="36576">
                     <a:solidFill>
                       <a:srgbClr val="FFFFFF"/>
                     </a:solidFill>
@@ -7311,7 +7311,7 @@
                     <a:lstStyle/>
                     <a:p>
                       <a:pPr>
-                        <a:defRPr sz="800">
+                        <a:defRPr sz="1000">
                           <a:solidFill>
                             <a:srgbClr val="334155"/>
                           </a:solidFill>
@@ -7322,7 +7322,7 @@
                       </a:r>
                     </a:p>
                   </a:txBody>
-                  <a:tcPr>
+                  <a:tcPr marL="54864" marR="36576" marT="36576" marB="36576">
                     <a:solidFill>
                       <a:srgbClr val="FFFFFF"/>
                     </a:solidFill>
@@ -7334,7 +7334,7 @@
                     <a:lstStyle/>
                     <a:p>
                       <a:pPr>
-                        <a:defRPr sz="800">
+                        <a:defRPr sz="1000">
                           <a:solidFill>
                             <a:srgbClr val="334155"/>
                           </a:solidFill>
@@ -7345,7 +7345,7 @@
                       </a:r>
                     </a:p>
                   </a:txBody>
-                  <a:tcPr>
+                  <a:tcPr marL="54864" marR="36576" marT="36576" marB="36576">
                     <a:solidFill>
                       <a:srgbClr val="FFFFFF"/>
                     </a:solidFill>
@@ -7357,7 +7357,7 @@
                     <a:lstStyle/>
                     <a:p>
                       <a:pPr>
-                        <a:defRPr sz="800">
+                        <a:defRPr sz="1000">
                           <a:solidFill>
                             <a:srgbClr val="334155"/>
                           </a:solidFill>
@@ -7368,7 +7368,7 @@
                       </a:r>
                     </a:p>
                   </a:txBody>
-                  <a:tcPr>
+                  <a:tcPr marL="54864" marR="36576" marT="36576" marB="36576">
                     <a:solidFill>
                       <a:srgbClr val="FFFFFF"/>
                     </a:solidFill>
@@ -7380,7 +7380,7 @@
                     <a:lstStyle/>
                     <a:p>
                       <a:pPr>
-                        <a:defRPr sz="800">
+                        <a:defRPr sz="1000">
                           <a:solidFill>
                             <a:srgbClr val="334155"/>
                           </a:solidFill>
@@ -7391,7 +7391,7 @@
                       </a:r>
                     </a:p>
                   </a:txBody>
-                  <a:tcPr>
+                  <a:tcPr marL="54864" marR="36576" marT="36576" marB="36576">
                     <a:solidFill>
                       <a:srgbClr val="FFFFFF"/>
                     </a:solidFill>
@@ -7735,7 +7735,7 @@
               </a:defRPr>
             </a:pPr>
             <a:r>
-              <a:t>3–5년: 원자력 SMR·양자 — LOI·건설·규제 마일스톤 구간</a:t>
+              <a:t>3–5년: 원자력 SMR(뉴스케일)·양자 — LOI·건설·규제 마일스톤 구간</a:t>
             </a:r>
           </a:p>
           <a:p>
@@ -8223,7 +8223,7 @@
           <a:p>
             <a:pPr>
               <a:lnSpc>
-                <a:spcPct val="115000"/>
+                <a:spcPct val="125000"/>
               </a:lnSpc>
               <a:spcAft>
                 <a:spcPts val="1200"/>
@@ -8235,13 +8235,13 @@
               </a:defRPr>
             </a:pPr>
             <a:r>
-              <a:t>1차 파생: AI 수요가 직접 올리는 회사 — Nvidia(GPU), Microsoft(Azure), OpenAI(API). 토큰·클라우드 사용량에 매출이 연동됩니다.</a:t>
+              <a:t>1차 파생: AI 수요가 직접 올리는 회사 — NVDA · 엔비디아(GPU), MSFT · 마이크로소프트(Azure), OpenAI(API). 토큰·클라우드 사용량에 매출이 연동됩니다.</a:t>
             </a:r>
           </a:p>
           <a:p>
             <a:pPr>
               <a:lnSpc>
-                <a:spcPct val="115000"/>
+                <a:spcPct val="125000"/>
               </a:lnSpc>
               <a:spcAft>
                 <a:spcPts val="1200"/>
@@ -8259,7 +8259,7 @@
           <a:p>
             <a:pPr>
               <a:lnSpc>
-                <a:spcPct val="115000"/>
+                <a:spcPct val="125000"/>
               </a:lnSpc>
               <a:spcAft>
                 <a:spcPts val="1200"/>
@@ -8277,7 +8277,7 @@
           <a:p>
             <a:pPr>
               <a:lnSpc>
-                <a:spcPct val="115000"/>
+                <a:spcPct val="125000"/>
               </a:lnSpc>
               <a:spcAft>
                 <a:spcPts val="1200"/>
@@ -8612,7 +8612,7 @@
               </a:defRPr>
             </a:pPr>
             <a:r>
-              <a:t>왼쪽: MSFT·META 등이 총 capex 결정</a:t>
+              <a:t>왼쪽: MSFT(마이크로소프트)·META(메타) 등이 총 capex 결정</a:t>
             </a:r>
           </a:p>
           <a:p>
@@ -8627,7 +8627,7 @@
               </a:defRPr>
             </a:pPr>
             <a:r>
-              <a:t>중간 2차(청색): 2026년 주가 상승의 중심 — VRT·ETN·PWR</a:t>
+              <a:t>중간 2차(청색): 2026년 주가 상승의 중심 — VRT(버티브)·ETN(이튼)·PWR(콴타 서비스)</a:t>
             </a:r>
           </a:p>
           <a:p>
@@ -8642,7 +8642,7 @@
               </a:defRPr>
             </a:pPr>
             <a:r>
-              <a:t>오른쪽 3차(녹색): 전력 생산 — CEG·VST (원자력 섹션과 연결)</a:t>
+              <a:t>오른쪽 3차(녹색): 전력 생산 — CEG(컨스텔레이션 에너지)·VST(비스트라) (원자력 섹션과 연결)</a:t>
             </a:r>
           </a:p>
         </p:txBody>
@@ -8865,7 +8865,7 @@
         <p:spPr>
           <a:xfrm>
             <a:off x="457200" y="1234440"/>
-            <a:ext cx="8229600" cy="1463040"/>
+            <a:ext cx="8229600" cy="1600200"/>
           </a:xfrm>
           <a:prstGeom prst="roundRect">
             <a:avLst/>
@@ -8987,8 +8987,8 @@
         </p:nvSpPr>
         <p:spPr>
           <a:xfrm>
-            <a:off x="1828800" y="1371600"/>
-            <a:ext cx="6675120" cy="1234440"/>
+            <a:off x="1828800" y="1344168"/>
+            <a:ext cx="6675120" cy="1325880"/>
           </a:xfrm>
           <a:prstGeom prst="rect">
             <a:avLst/>
@@ -9014,14 +9014,26 @@
           </a:p>
           <a:p>
             <a:pPr>
-              <a:defRPr sz="1100">
+              <a:defRPr sz="1000">
                 <a:solidFill>
                   <a:srgbClr val="334155"/>
                 </a:solidFill>
               </a:defRPr>
             </a:pPr>
             <a:r>
-              <a:t>NVDA·AVGO·MRVL — AI 연산 자체. CUDA·커스텀 ASIC moat.</a:t>
+              <a:t>NVDA · 엔비디아</a:t>
+            </a:r>
+            <a:br/>
+            <a:r>
+              <a:t>AVGO · 브로드컴</a:t>
+            </a:r>
+            <a:br/>
+            <a:r>
+              <a:t>MRVL · 마벨</a:t>
+            </a:r>
+            <a:br/>
+            <a:r>
+              <a:t>— GPU·커스텀 ASIC. AI 연산의 핵심.</a:t>
             </a:r>
           </a:p>
         </p:txBody>
@@ -9034,8 +9046,8 @@
         </p:nvSpPr>
         <p:spPr>
           <a:xfrm>
-            <a:off x="457200" y="2926080"/>
-            <a:ext cx="8229600" cy="1463040"/>
+            <a:off x="457200" y="3017520"/>
+            <a:ext cx="8229600" cy="1600200"/>
           </a:xfrm>
           <a:prstGeom prst="roundRect">
             <a:avLst/>
@@ -9079,7 +9091,7 @@
         </p:nvSpPr>
         <p:spPr>
           <a:xfrm>
-            <a:off x="594360" y="3108960"/>
+            <a:off x="594360" y="3200400"/>
             <a:ext cx="1097280" cy="1097280"/>
           </a:xfrm>
           <a:prstGeom prst="roundRect">
@@ -9122,7 +9134,7 @@
         </p:nvSpPr>
         <p:spPr>
           <a:xfrm>
-            <a:off x="594360" y="3337560"/>
+            <a:off x="594360" y="3429000"/>
             <a:ext cx="1097280" cy="640080"/>
           </a:xfrm>
           <a:prstGeom prst="rect">
@@ -9157,8 +9169,8 @@
         </p:nvSpPr>
         <p:spPr>
           <a:xfrm>
-            <a:off x="1828800" y="3063240"/>
-            <a:ext cx="6675120" cy="1234440"/>
+            <a:off x="1828800" y="3127248"/>
+            <a:ext cx="6675120" cy="1325880"/>
           </a:xfrm>
           <a:prstGeom prst="rect">
             <a:avLst/>
@@ -9184,14 +9196,26 @@
           </a:p>
           <a:p>
             <a:pPr>
-              <a:defRPr sz="1100">
+              <a:defRPr sz="1000">
                 <a:solidFill>
                   <a:srgbClr val="334155"/>
                 </a:solidFill>
               </a:defRPr>
             </a:pPr>
             <a:r>
-              <a:t>VRT·ETN·ABB — 랙 안팎의 전력분배·액침냉각. AI DC 매출 비중 급증.</a:t>
+              <a:t>VRT · 버티브</a:t>
+            </a:r>
+            <a:br/>
+            <a:r>
+              <a:t>ETN · 이튼</a:t>
+            </a:r>
+            <a:br/>
+            <a:r>
+              <a:t>ABB · ABB</a:t>
+            </a:r>
+            <a:br/>
+            <a:r>
+              <a:t>— 랙 전력분배·액침냉각. AI DC 매출 비중 급증.</a:t>
             </a:r>
           </a:p>
         </p:txBody>
@@ -9204,8 +9228,8 @@
         </p:nvSpPr>
         <p:spPr>
           <a:xfrm>
-            <a:off x="457200" y="4617720"/>
-            <a:ext cx="8229600" cy="1463040"/>
+            <a:off x="457200" y="4800600"/>
+            <a:ext cx="8229600" cy="1600200"/>
           </a:xfrm>
           <a:prstGeom prst="roundRect">
             <a:avLst/>
@@ -9249,7 +9273,7 @@
         </p:nvSpPr>
         <p:spPr>
           <a:xfrm>
-            <a:off x="594360" y="4800600"/>
+            <a:off x="594360" y="4983480"/>
             <a:ext cx="1097280" cy="1097280"/>
           </a:xfrm>
           <a:prstGeom prst="roundRect">
@@ -9292,7 +9316,7 @@
         </p:nvSpPr>
         <p:spPr>
           <a:xfrm>
-            <a:off x="594360" y="5029200"/>
+            <a:off x="594360" y="5212080"/>
             <a:ext cx="1097280" cy="640080"/>
           </a:xfrm>
           <a:prstGeom prst="rect">
@@ -9327,8 +9351,8 @@
         </p:nvSpPr>
         <p:spPr>
           <a:xfrm>
-            <a:off x="1828800" y="4754880"/>
-            <a:ext cx="6675120" cy="1234440"/>
+            <a:off x="1828800" y="4910328"/>
+            <a:ext cx="6675120" cy="1325880"/>
           </a:xfrm>
           <a:prstGeom prst="rect">
             <a:avLst/>
@@ -9354,14 +9378,30 @@
           </a:p>
           <a:p>
             <a:pPr>
-              <a:defRPr sz="1100">
+              <a:defRPr sz="1000">
                 <a:solidFill>
                   <a:srgbClr val="334155"/>
                 </a:solidFill>
               </a:defRPr>
             </a:pPr>
             <a:r>
-              <a:t>CAT·PWR·GNRC·STX — DC 건설, 송전선, 디젤 백업, 학습 데이터 저장.</a:t>
+              <a:t>CAT · 캐터필러</a:t>
+            </a:r>
+            <a:br/>
+            <a:r>
+              <a:t>PWR · 콴타 서비스</a:t>
+            </a:r>
+            <a:br/>
+            <a:r>
+              <a:t>GNRC · 제네락</a:t>
+            </a:r>
+            <a:br/>
+            <a:r>
+              <a:t>STX · 씨게이트</a:t>
+            </a:r>
+            <a:br/>
+            <a:r>
+              <a:t>— DC 건설·송전·백업발전·데이터 저장.</a:t>
             </a:r>
           </a:p>
         </p:txBody>
@@ -9561,7 +9601,7 @@
         </p:nvGraphicFramePr>
         <p:xfrm>
           <a:off x="365760" y="1143000"/>
-          <a:ext cx="6537960" cy="2231136"/>
+          <a:ext cx="6766560" cy="2916936"/>
         </p:xfrm>
         <a:graphic>
           <a:graphicData uri="http://schemas.openxmlformats.org/drawingml/2006/table">
@@ -9570,26 +9610,26 @@
                 <a:tableStyleId>{5C22544A-7EE6-4342-B048-85BDC9FD1C3A}</a:tableStyleId>
               </a:tblPr>
               <a:tblGrid>
-                <a:gridCol w="594360"/>
-                <a:gridCol w="1828800"/>
-                <a:gridCol w="2286000"/>
+                <a:gridCol w="1005840"/>
+                <a:gridCol w="1737360"/>
+                <a:gridCol w="2194560"/>
                 <a:gridCol w="1828800"/>
               </a:tblGrid>
-              <a:tr h="318733">
+              <a:tr h="416705">
                 <a:tc>
                   <a:txBody>
                     <a:bodyPr/>
                     <a:lstStyle/>
                     <a:p>
                       <a:pPr>
-                        <a:defRPr b="1" sz="900">
+                        <a:defRPr b="1" sz="1100">
                           <a:solidFill>
                             <a:srgbClr val="FFFFFF"/>
                           </a:solidFill>
                         </a:defRPr>
                       </a:pPr>
                       <a:r>
-                        <a:t>티커</a:t>
+                        <a:t>종목</a:t>
                       </a:r>
                     </a:p>
                   </a:txBody>
@@ -9605,7 +9645,7 @@
                     <a:lstStyle/>
                     <a:p>
                       <a:pPr>
-                        <a:defRPr b="1" sz="900">
+                        <a:defRPr b="1" sz="1100">
                           <a:solidFill>
                             <a:srgbClr val="FFFFFF"/>
                           </a:solidFill>
@@ -9628,7 +9668,7 @@
                     <a:lstStyle/>
                     <a:p>
                       <a:pPr>
-                        <a:defRPr b="1" sz="900">
+                        <a:defRPr b="1" sz="1100">
                           <a:solidFill>
                             <a:srgbClr val="FFFFFF"/>
                           </a:solidFill>
@@ -9651,7 +9691,7 @@
                     <a:lstStyle/>
                     <a:p>
                       <a:pPr>
-                        <a:defRPr b="1" sz="900">
+                        <a:defRPr b="1" sz="1100">
                           <a:solidFill>
                             <a:srgbClr val="FFFFFF"/>
                           </a:solidFill>
@@ -9669,16 +9709,16 @@
                   </a:tcPr>
                 </a:tc>
               </a:tr>
-              <a:tr h="318733">
+              <a:tr h="416705">
                 <a:tc>
                   <a:txBody>
                     <a:bodyPr/>
                     <a:lstStyle/>
                     <a:p>
                       <a:pPr>
-                        <a:defRPr sz="800">
+                        <a:defRPr b="1" sz="1100">
                           <a:solidFill>
-                            <a:srgbClr val="334155"/>
+                            <a:srgbClr val="0F172A"/>
                           </a:solidFill>
                         </a:defRPr>
                       </a:pPr>
@@ -9686,8 +9726,20 @@
                         <a:t>VRT</a:t>
                       </a:r>
                     </a:p>
+                    <a:p>
+                      <a:pPr>
+                        <a:defRPr sz="1000">
+                          <a:solidFill>
+                            <a:srgbClr val="94A3B8"/>
+                          </a:solidFill>
+                        </a:defRPr>
+                      </a:pPr>
+                      <a:r>
+                        <a:t>버티브</a:t>
+                      </a:r>
+                    </a:p>
                   </a:txBody>
-                  <a:tcPr>
+                  <a:tcPr marL="54864" marR="36576" marT="36576" marB="36576">
                     <a:solidFill>
                       <a:srgbClr val="F8FAFC"/>
                     </a:solidFill>
@@ -9699,7 +9751,7 @@
                     <a:lstStyle/>
                     <a:p>
                       <a:pPr>
-                        <a:defRPr sz="800">
+                        <a:defRPr sz="1000">
                           <a:solidFill>
                             <a:srgbClr val="334155"/>
                           </a:solidFill>
@@ -9710,7 +9762,7 @@
                       </a:r>
                     </a:p>
                   </a:txBody>
-                  <a:tcPr>
+                  <a:tcPr marL="54864" marR="36576" marT="36576" marB="36576">
                     <a:solidFill>
                       <a:srgbClr val="F8FAFC"/>
                     </a:solidFill>
@@ -9722,7 +9774,7 @@
                     <a:lstStyle/>
                     <a:p>
                       <a:pPr>
-                        <a:defRPr sz="800">
+                        <a:defRPr sz="1000">
                           <a:solidFill>
                             <a:srgbClr val="334155"/>
                           </a:solidFill>
@@ -9733,7 +9785,7 @@
                       </a:r>
                     </a:p>
                   </a:txBody>
-                  <a:tcPr>
+                  <a:tcPr marL="54864" marR="36576" marT="36576" marB="36576">
                     <a:solidFill>
                       <a:srgbClr val="F8FAFC"/>
                     </a:solidFill>
@@ -9745,7 +9797,7 @@
                     <a:lstStyle/>
                     <a:p>
                       <a:pPr>
-                        <a:defRPr sz="800">
+                        <a:defRPr sz="1000">
                           <a:solidFill>
                             <a:srgbClr val="334155"/>
                           </a:solidFill>
@@ -9756,23 +9808,23 @@
                       </a:r>
                     </a:p>
                   </a:txBody>
-                  <a:tcPr>
+                  <a:tcPr marL="54864" marR="36576" marT="36576" marB="36576">
                     <a:solidFill>
                       <a:srgbClr val="F8FAFC"/>
                     </a:solidFill>
                   </a:tcPr>
                 </a:tc>
               </a:tr>
-              <a:tr h="318733">
+              <a:tr h="416705">
                 <a:tc>
                   <a:txBody>
                     <a:bodyPr/>
                     <a:lstStyle/>
                     <a:p>
                       <a:pPr>
-                        <a:defRPr sz="800">
+                        <a:defRPr b="1" sz="1100">
                           <a:solidFill>
-                            <a:srgbClr val="334155"/>
+                            <a:srgbClr val="0F172A"/>
                           </a:solidFill>
                         </a:defRPr>
                       </a:pPr>
@@ -9780,8 +9832,20 @@
                         <a:t>ETN</a:t>
                       </a:r>
                     </a:p>
+                    <a:p>
+                      <a:pPr>
+                        <a:defRPr sz="1000">
+                          <a:solidFill>
+                            <a:srgbClr val="94A3B8"/>
+                          </a:solidFill>
+                        </a:defRPr>
+                      </a:pPr>
+                      <a:r>
+                        <a:t>이튼</a:t>
+                      </a:r>
+                    </a:p>
                   </a:txBody>
-                  <a:tcPr>
+                  <a:tcPr marL="54864" marR="36576" marT="36576" marB="36576">
                     <a:solidFill>
                       <a:srgbClr val="FFFFFF"/>
                     </a:solidFill>
@@ -9793,7 +9857,7 @@
                     <a:lstStyle/>
                     <a:p>
                       <a:pPr>
-                        <a:defRPr sz="800">
+                        <a:defRPr sz="1000">
                           <a:solidFill>
                             <a:srgbClr val="334155"/>
                           </a:solidFill>
@@ -9804,7 +9868,7 @@
                       </a:r>
                     </a:p>
                   </a:txBody>
-                  <a:tcPr>
+                  <a:tcPr marL="54864" marR="36576" marT="36576" marB="36576">
                     <a:solidFill>
                       <a:srgbClr val="FFFFFF"/>
                     </a:solidFill>
@@ -9816,18 +9880,18 @@
                     <a:lstStyle/>
                     <a:p>
                       <a:pPr>
-                        <a:defRPr sz="800">
+                        <a:defRPr sz="1000">
                           <a:solidFill>
                             <a:srgbClr val="334155"/>
                           </a:solidFill>
                         </a:defRPr>
                       </a:pPr>
                       <a:r>
-                        <a:t>VRT 대비 저변동, AI 15%+</a:t>
+                        <a:t>버티브 대비 저변동, AI 15%+</a:t>
                       </a:r>
                     </a:p>
                   </a:txBody>
-                  <a:tcPr>
+                  <a:tcPr marL="54864" marR="36576" marT="36576" marB="36576">
                     <a:solidFill>
                       <a:srgbClr val="FFFFFF"/>
                     </a:solidFill>
@@ -9839,7 +9903,7 @@
                     <a:lstStyle/>
                     <a:p>
                       <a:pPr>
-                        <a:defRPr sz="800">
+                        <a:defRPr sz="1000">
                           <a:solidFill>
                             <a:srgbClr val="334155"/>
                           </a:solidFill>
@@ -9850,23 +9914,23 @@
                       </a:r>
                     </a:p>
                   </a:txBody>
-                  <a:tcPr>
+                  <a:tcPr marL="54864" marR="36576" marT="36576" marB="36576">
                     <a:solidFill>
                       <a:srgbClr val="FFFFFF"/>
                     </a:solidFill>
                   </a:tcPr>
                 </a:tc>
               </a:tr>
-              <a:tr h="318733">
+              <a:tr h="416705">
                 <a:tc>
                   <a:txBody>
                     <a:bodyPr/>
                     <a:lstStyle/>
                     <a:p>
                       <a:pPr>
-                        <a:defRPr sz="800">
+                        <a:defRPr b="1" sz="1100">
                           <a:solidFill>
-                            <a:srgbClr val="334155"/>
+                            <a:srgbClr val="0F172A"/>
                           </a:solidFill>
                         </a:defRPr>
                       </a:pPr>
@@ -9874,8 +9938,20 @@
                         <a:t>PWR</a:t>
                       </a:r>
                     </a:p>
+                    <a:p>
+                      <a:pPr>
+                        <a:defRPr sz="1000">
+                          <a:solidFill>
+                            <a:srgbClr val="94A3B8"/>
+                          </a:solidFill>
+                        </a:defRPr>
+                      </a:pPr>
+                      <a:r>
+                        <a:t>콴타 서비스</a:t>
+                      </a:r>
+                    </a:p>
                   </a:txBody>
-                  <a:tcPr>
+                  <a:tcPr marL="54864" marR="36576" marT="36576" marB="36576">
                     <a:solidFill>
                       <a:srgbClr val="F8FAFC"/>
                     </a:solidFill>
@@ -9887,7 +9963,7 @@
                     <a:lstStyle/>
                     <a:p>
                       <a:pPr>
-                        <a:defRPr sz="800">
+                        <a:defRPr sz="1000">
                           <a:solidFill>
                             <a:srgbClr val="334155"/>
                           </a:solidFill>
@@ -9898,7 +9974,7 @@
                       </a:r>
                     </a:p>
                   </a:txBody>
-                  <a:tcPr>
+                  <a:tcPr marL="54864" marR="36576" marT="36576" marB="36576">
                     <a:solidFill>
                       <a:srgbClr val="F8FAFC"/>
                     </a:solidFill>
@@ -9910,7 +9986,7 @@
                     <a:lstStyle/>
                     <a:p>
                       <a:pPr>
-                        <a:defRPr sz="800">
+                        <a:defRPr sz="1000">
                           <a:solidFill>
                             <a:srgbClr val="334155"/>
                           </a:solidFill>
@@ -9921,7 +9997,7 @@
                       </a:r>
                     </a:p>
                   </a:txBody>
-                  <a:tcPr>
+                  <a:tcPr marL="54864" marR="36576" marT="36576" marB="36576">
                     <a:solidFill>
                       <a:srgbClr val="F8FAFC"/>
                     </a:solidFill>
@@ -9933,7 +10009,7 @@
                     <a:lstStyle/>
                     <a:p>
                       <a:pPr>
-                        <a:defRPr sz="800">
+                        <a:defRPr sz="1000">
                           <a:solidFill>
                             <a:srgbClr val="334155"/>
                           </a:solidFill>
@@ -9944,23 +10020,23 @@
                       </a:r>
                     </a:p>
                   </a:txBody>
-                  <a:tcPr>
+                  <a:tcPr marL="54864" marR="36576" marT="36576" marB="36576">
                     <a:solidFill>
                       <a:srgbClr val="F8FAFC"/>
                     </a:solidFill>
                   </a:tcPr>
                 </a:tc>
               </a:tr>
-              <a:tr h="318733">
+              <a:tr h="416705">
                 <a:tc>
                   <a:txBody>
                     <a:bodyPr/>
                     <a:lstStyle/>
                     <a:p>
                       <a:pPr>
-                        <a:defRPr sz="800">
+                        <a:defRPr b="1" sz="1100">
                           <a:solidFill>
-                            <a:srgbClr val="334155"/>
+                            <a:srgbClr val="0F172A"/>
                           </a:solidFill>
                         </a:defRPr>
                       </a:pPr>
@@ -9968,8 +10044,20 @@
                         <a:t>NVDA</a:t>
                       </a:r>
                     </a:p>
+                    <a:p>
+                      <a:pPr>
+                        <a:defRPr sz="1000">
+                          <a:solidFill>
+                            <a:srgbClr val="94A3B8"/>
+                          </a:solidFill>
+                        </a:defRPr>
+                      </a:pPr>
+                      <a:r>
+                        <a:t>엔비디아</a:t>
+                      </a:r>
+                    </a:p>
                   </a:txBody>
-                  <a:tcPr>
+                  <a:tcPr marL="54864" marR="36576" marT="36576" marB="36576">
                     <a:solidFill>
                       <a:srgbClr val="FFFFFF"/>
                     </a:solidFill>
@@ -9981,7 +10069,7 @@
                     <a:lstStyle/>
                     <a:p>
                       <a:pPr>
-                        <a:defRPr sz="800">
+                        <a:defRPr sz="1000">
                           <a:solidFill>
                             <a:srgbClr val="334155"/>
                           </a:solidFill>
@@ -9992,7 +10080,7 @@
                       </a:r>
                     </a:p>
                   </a:txBody>
-                  <a:tcPr>
+                  <a:tcPr marL="54864" marR="36576" marT="36576" marB="36576">
                     <a:solidFill>
                       <a:srgbClr val="FFFFFF"/>
                     </a:solidFill>
@@ -10004,7 +10092,7 @@
                     <a:lstStyle/>
                     <a:p>
                       <a:pPr>
-                        <a:defRPr sz="800">
+                        <a:defRPr sz="1000">
                           <a:solidFill>
                             <a:srgbClr val="334155"/>
                           </a:solidFill>
@@ -10015,7 +10103,7 @@
                       </a:r>
                     </a:p>
                   </a:txBody>
-                  <a:tcPr>
+                  <a:tcPr marL="54864" marR="36576" marT="36576" marB="36576">
                     <a:solidFill>
                       <a:srgbClr val="FFFFFF"/>
                     </a:solidFill>
@@ -10027,7 +10115,7 @@
                     <a:lstStyle/>
                     <a:p>
                       <a:pPr>
-                        <a:defRPr sz="800">
+                        <a:defRPr sz="1000">
                           <a:solidFill>
                             <a:srgbClr val="334155"/>
                           </a:solidFill>
@@ -10038,23 +10126,23 @@
                       </a:r>
                     </a:p>
                   </a:txBody>
-                  <a:tcPr>
+                  <a:tcPr marL="54864" marR="36576" marT="36576" marB="36576">
                     <a:solidFill>
                       <a:srgbClr val="FFFFFF"/>
                     </a:solidFill>
                   </a:tcPr>
                 </a:tc>
               </a:tr>
-              <a:tr h="318733">
+              <a:tr h="416705">
                 <a:tc>
                   <a:txBody>
                     <a:bodyPr/>
                     <a:lstStyle/>
                     <a:p>
                       <a:pPr>
-                        <a:defRPr sz="800">
+                        <a:defRPr b="1" sz="1100">
                           <a:solidFill>
-                            <a:srgbClr val="334155"/>
+                            <a:srgbClr val="0F172A"/>
                           </a:solidFill>
                         </a:defRPr>
                       </a:pPr>
@@ -10062,8 +10150,20 @@
                         <a:t>AVGO</a:t>
                       </a:r>
                     </a:p>
+                    <a:p>
+                      <a:pPr>
+                        <a:defRPr sz="1000">
+                          <a:solidFill>
+                            <a:srgbClr val="94A3B8"/>
+                          </a:solidFill>
+                        </a:defRPr>
+                      </a:pPr>
+                      <a:r>
+                        <a:t>브로드컴</a:t>
+                      </a:r>
+                    </a:p>
                   </a:txBody>
-                  <a:tcPr>
+                  <a:tcPr marL="54864" marR="36576" marT="36576" marB="36576">
                     <a:solidFill>
                       <a:srgbClr val="F8FAFC"/>
                     </a:solidFill>
@@ -10075,18 +10175,18 @@
                     <a:lstStyle/>
                     <a:p>
                       <a:pPr>
-                        <a:defRPr sz="800">
+                        <a:defRPr sz="1000">
                           <a:solidFill>
                             <a:srgbClr val="334155"/>
                           </a:solidFill>
                         </a:defRPr>
                       </a:pPr>
                       <a:r>
-                        <a:t>Google/Meta ASIC</a:t>
+                        <a:t>GOOGL · 알파벳/Meta ASIC</a:t>
                       </a:r>
                     </a:p>
                   </a:txBody>
-                  <a:tcPr>
+                  <a:tcPr marL="54864" marR="36576" marT="36576" marB="36576">
                     <a:solidFill>
                       <a:srgbClr val="F8FAFC"/>
                     </a:solidFill>
@@ -10098,7 +10198,7 @@
                     <a:lstStyle/>
                     <a:p>
                       <a:pPr>
-                        <a:defRPr sz="800">
+                        <a:defRPr sz="1000">
                           <a:solidFill>
                             <a:srgbClr val="334155"/>
                           </a:solidFill>
@@ -10109,7 +10209,7 @@
                       </a:r>
                     </a:p>
                   </a:txBody>
-                  <a:tcPr>
+                  <a:tcPr marL="54864" marR="36576" marT="36576" marB="36576">
                     <a:solidFill>
                       <a:srgbClr val="F8FAFC"/>
                     </a:solidFill>
@@ -10121,7 +10221,7 @@
                     <a:lstStyle/>
                     <a:p>
                       <a:pPr>
-                        <a:defRPr sz="800">
+                        <a:defRPr sz="1000">
                           <a:solidFill>
                             <a:srgbClr val="334155"/>
                           </a:solidFill>
@@ -10132,23 +10232,23 @@
                       </a:r>
                     </a:p>
                   </a:txBody>
-                  <a:tcPr>
+                  <a:tcPr marL="54864" marR="36576" marT="36576" marB="36576">
                     <a:solidFill>
                       <a:srgbClr val="F8FAFC"/>
                     </a:solidFill>
                   </a:tcPr>
                 </a:tc>
               </a:tr>
-              <a:tr h="318738">
+              <a:tr h="416706">
                 <a:tc>
                   <a:txBody>
                     <a:bodyPr/>
                     <a:lstStyle/>
                     <a:p>
                       <a:pPr>
-                        <a:defRPr sz="800">
+                        <a:defRPr b="1" sz="1100">
                           <a:solidFill>
-                            <a:srgbClr val="334155"/>
+                            <a:srgbClr val="0F172A"/>
                           </a:solidFill>
                         </a:defRPr>
                       </a:pPr>
@@ -10156,8 +10256,20 @@
                         <a:t>CAT</a:t>
                       </a:r>
                     </a:p>
+                    <a:p>
+                      <a:pPr>
+                        <a:defRPr sz="1000">
+                          <a:solidFill>
+                            <a:srgbClr val="94A3B8"/>
+                          </a:solidFill>
+                        </a:defRPr>
+                      </a:pPr>
+                      <a:r>
+                        <a:t>캐터필러</a:t>
+                      </a:r>
+                    </a:p>
                   </a:txBody>
-                  <a:tcPr>
+                  <a:tcPr marL="54864" marR="36576" marT="36576" marB="36576">
                     <a:solidFill>
                       <a:srgbClr val="FFFFFF"/>
                     </a:solidFill>
@@ -10169,7 +10281,7 @@
                     <a:lstStyle/>
                     <a:p>
                       <a:pPr>
-                        <a:defRPr sz="800">
+                        <a:defRPr sz="1000">
                           <a:solidFill>
                             <a:srgbClr val="334155"/>
                           </a:solidFill>
@@ -10180,7 +10292,7 @@
                       </a:r>
                     </a:p>
                   </a:txBody>
-                  <a:tcPr>
+                  <a:tcPr marL="54864" marR="36576" marT="36576" marB="36576">
                     <a:solidFill>
                       <a:srgbClr val="FFFFFF"/>
                     </a:solidFill>
@@ -10192,7 +10304,7 @@
                     <a:lstStyle/>
                     <a:p>
                       <a:pPr>
-                        <a:defRPr sz="800">
+                        <a:defRPr sz="1000">
                           <a:solidFill>
                             <a:srgbClr val="334155"/>
                           </a:solidFill>
@@ -10203,7 +10315,7 @@
                       </a:r>
                     </a:p>
                   </a:txBody>
-                  <a:tcPr>
+                  <a:tcPr marL="54864" marR="36576" marT="36576" marB="36576">
                     <a:solidFill>
                       <a:srgbClr val="FFFFFF"/>
                     </a:solidFill>
@@ -10215,7 +10327,7 @@
                     <a:lstStyle/>
                     <a:p>
                       <a:pPr>
-                        <a:defRPr sz="800">
+                        <a:defRPr sz="1000">
                           <a:solidFill>
                             <a:srgbClr val="334155"/>
                           </a:solidFill>
@@ -10226,7 +10338,7 @@
                       </a:r>
                     </a:p>
                   </a:txBody>
-                  <a:tcPr>
+                  <a:tcPr marL="54864" marR="36576" marT="36576" marB="36576">
                     <a:solidFill>
                       <a:srgbClr val="FFFFFF"/>
                     </a:solidFill>
@@ -11786,7 +11898,7 @@
           <a:p>
             <a:pPr>
               <a:lnSpc>
-                <a:spcPct val="115000"/>
+                <a:spcPct val="125000"/>
               </a:lnSpc>
               <a:spcAft>
                 <a:spcPts val="1200"/>
@@ -11804,7 +11916,7 @@
           <a:p>
             <a:pPr>
               <a:lnSpc>
-                <a:spcPct val="115000"/>
+                <a:spcPct val="125000"/>
               </a:lnSpc>
               <a:spcAft>
                 <a:spcPts val="1200"/>
@@ -11822,7 +11934,7 @@
           <a:p>
             <a:pPr>
               <a:lnSpc>
-                <a:spcPct val="115000"/>
+                <a:spcPct val="125000"/>
               </a:lnSpc>
               <a:spcAft>
                 <a:spcPts val="1200"/>
@@ -11840,7 +11952,7 @@
           <a:p>
             <a:pPr>
               <a:lnSpc>
-                <a:spcPct val="115000"/>
+                <a:spcPct val="125000"/>
               </a:lnSpc>
               <a:spcAft>
                 <a:spcPts val="1200"/>
@@ -11852,7 +11964,7 @@
               </a:defRPr>
             </a:pPr>
             <a:r>
-              <a:t>2024–26년 Microsoft–Constellation(TMI 재가동), Meta–6.6GW 패키지 등이 '선례'가 됐고, 이후 발주는 이 선례를 따릅니다.</a:t>
+              <a:t>2024–26년 MSFT · 마이크로소프트–Constellation(TMI 재가동), Meta–6.6GW 패키지 등이 '선례'가 됐고, 이후 발주는 이 선례를 따릅니다.</a:t>
             </a:r>
           </a:p>
         </p:txBody>
@@ -12175,7 +12287,7 @@
               </a:defRPr>
             </a:pPr>
             <a:r>
-              <a:t>녹색 = 이미 돌아가는 원전에서 전력 공급 (CEG, VST) → 매출·현금흐름 즉시</a:t>
+              <a:t>녹색 = 이미 돌아가는 원전에서 전력 공급 (CEG(컨스텔레이션 에너지), VST(비스트라)) → 매출·현금흐름 즉시</a:t>
             </a:r>
           </a:p>
           <a:p>
@@ -12190,7 +12302,7 @@
               </a:defRPr>
             </a:pPr>
             <a:r>
-              <a:t>주황 = SMR(소형모듈로) — 2030–35 가동 예정 → 지금은 주가에 '옵션' 반영</a:t>
+              <a:t>주황 = SMR(뉴스케일)(소형모듈로) — 2030–35 가동 예정 → 지금은 주가에 '옵션' 반영</a:t>
             </a:r>
           </a:p>
           <a:p>
@@ -12205,7 +12317,7 @@
               </a:defRPr>
             </a:pPr>
             <a:r>
-              <a:t>투자 시: Bucket 1(유틸)과 Bucket 2(SMR)는 완전히 다른 리스크</a:t>
+              <a:t>투자 시: Bucket 1(유틸)과 Bucket 2(SMR(뉴스케일))는 완전히 다른 리스크</a:t>
             </a:r>
           </a:p>
         </p:txBody>
@@ -12499,14 +12611,26 @@
           </a:p>
           <a:p>
             <a:pPr>
-              <a:defRPr sz="1200" b="1">
+              <a:defRPr sz="1000" b="0">
                 <a:solidFill>
                   <a:srgbClr val="0F172A"/>
                 </a:solidFill>
               </a:defRPr>
             </a:pPr>
             <a:r>
-              <a:t>CEG · VST · TLN · D</a:t>
+              <a:t>CEG · 컨스텔레이션 에너지</a:t>
+            </a:r>
+            <a:br/>
+            <a:r>
+              <a:t>VST · 비스트라</a:t>
+            </a:r>
+            <a:br/>
+            <a:r>
+              <a:t>TLN · 탈렌 에너지</a:t>
+            </a:r>
+            <a:br/>
+            <a:r>
+              <a:t>D · 도미니언 에너지</a:t>
             </a:r>
           </a:p>
           <a:p>
@@ -12603,14 +12727,22 @@
           </a:p>
           <a:p>
             <a:pPr>
-              <a:defRPr sz="1200" b="1">
+              <a:defRPr sz="1000" b="0">
                 <a:solidFill>
                   <a:srgbClr val="0F172A"/>
                 </a:solidFill>
               </a:defRPr>
             </a:pPr>
             <a:r>
-              <a:t>OKLO · SMR · NNE</a:t>
+              <a:t>OKLO · 오클로</a:t>
+            </a:r>
+            <a:br/>
+            <a:r>
+              <a:t>SMR · 뉴스케일</a:t>
+            </a:r>
+            <a:br/>
+            <a:r>
+              <a:t>NNE · 나노 뉴클리어</a:t>
             </a:r>
           </a:p>
           <a:p>
@@ -12707,14 +12839,26 @@
           </a:p>
           <a:p>
             <a:pPr>
-              <a:defRPr sz="1200" b="1">
+              <a:defRPr sz="1000" b="0">
                 <a:solidFill>
                   <a:srgbClr val="0F172A"/>
                 </a:solidFill>
               </a:defRPr>
             </a:pPr>
             <a:r>
-              <a:t>CCJ · BWXT · LEU · GEV</a:t>
+              <a:t>CCJ · 카메코</a:t>
+            </a:r>
+            <a:br/>
+            <a:r>
+              <a:t>BWXT · BWX 테크놀로지</a:t>
+            </a:r>
+            <a:br/>
+            <a:r>
+              <a:t>LEU · 센트러스 에너지</a:t>
+            </a:r>
+            <a:br/>
+            <a:r>
+              <a:t>GEV · GE 버노바</a:t>
             </a:r>
           </a:p>
           <a:p>
@@ -13175,7 +13319,7 @@
           <a:p>
             <a:pPr>
               <a:lnSpc>
-                <a:spcPct val="115000"/>
+                <a:spcPct val="125000"/>
               </a:lnSpc>
               <a:spcAft>
                 <a:spcPts val="1200"/>
@@ -13187,13 +13331,13 @@
               </a:defRPr>
             </a:pPr>
             <a:r>
-              <a:t>첨단 칩의 90% 이상이 대만(TSMC)에 집중돼 있다는 것은 미국에게 국가 안보 리스크입니다. 2022년 CHIPS Act는 이를 해소하기 위한 $52.7B+ 패키지입니다.</a:t>
+              <a:t>첨단 칩의 90% 이상이 대만(TSM · TSMC)에 집중돼 있다는 것은 미국에게 국가 안보 리스크입니다. 2022년 CHIPS Act는 이를 해소하기 위한 $52.7B+ 패키지입니다.</a:t>
             </a:r>
           </a:p>
           <a:p>
             <a:pPr>
               <a:lnSpc>
-                <a:spcPct val="115000"/>
+                <a:spcPct val="125000"/>
               </a:lnSpc>
               <a:spcAft>
                 <a:spcPts val="1200"/>
@@ -13205,13 +13349,13 @@
               </a:defRPr>
             </a:pPr>
             <a:r>
-              <a:t>직접 지원: Intel $8.5B, TSMC $6.6B, Samsung, Micron 등 — fab 건설·현대화.</a:t>
+              <a:t>직접 지원: INTC · 인텔 $8.5B, TSM · TSMC $6.6B, 삼성전자, MU · 마이크론 등 — fab 건설·현대화.</a:t>
             </a:r>
           </a:p>
           <a:p>
             <a:pPr>
               <a:lnSpc>
-                <a:spcPct val="115000"/>
+                <a:spcPct val="125000"/>
               </a:lnSpc>
               <a:spcAft>
                 <a:spcPts val="1200"/>
@@ -13229,7 +13373,7 @@
           <a:p>
             <a:pPr>
               <a:lnSpc>
-                <a:spcPct val="115000"/>
+                <a:spcPct val="125000"/>
               </a:lnSpc>
               <a:spcAft>
                 <a:spcPts val="1200"/>
@@ -13241,7 +13385,7 @@
               </a:defRPr>
             </a:pPr>
             <a:r>
-              <a:t>투자 포인트: (A) Fab 운영사 Intel·TSM — turnaround/성장 (B) 장비사 AMAT·LRCX·ASML — fab가 늘면 주문이 늘음, CHIPS 의존도 낮음.</a:t>
+              <a:t>투자 포인트: (A) Fab 운영사 INTC · 인텔·TSM(TSM · TSMC) — turnaround/성장 (B) 장비사 AMAT(어플라이드 머티리얼즈)·LRCX(램리서치)·ASML(ASML) — fab가 늘면 주문이 늘음, CHIPS 의존도 낮음.</a:t>
             </a:r>
           </a:p>
         </p:txBody>
@@ -13995,7 +14139,7 @@
           <a:p>
             <a:pPr>
               <a:lnSpc>
-                <a:spcPct val="115000"/>
+                <a:spcPct val="125000"/>
               </a:lnSpc>
               <a:spcAft>
                 <a:spcPts val="1000"/>
@@ -14007,13 +14151,13 @@
               </a:defRPr>
             </a:pPr>
             <a:r>
-              <a:t>Intel Ohio는 2030으로 지연됐지만, '착공'만 2026 안에 하면 세액공제는 유지 — 실제 wafer 출하는 몇 년 뒤일 수 있음.</a:t>
+              <a:t>INTC · 인텔 Ohio는 2030으로 지연됐지만, '착공'만 2026 안에 하면 세액공제는 유지 — 실제 wafer 출하는 몇 년 뒤일 수 있음.</a:t>
             </a:r>
           </a:p>
           <a:p>
             <a:pPr>
               <a:lnSpc>
-                <a:spcPct val="115000"/>
+                <a:spcPct val="125000"/>
               </a:lnSpc>
               <a:spcAft>
                 <a:spcPts val="1000"/>
@@ -14025,13 +14169,13 @@
               </a:defRPr>
             </a:pPr>
             <a:r>
-              <a:t>Intel 18A(Arizona)는 이미 HVM(대량생산) — 미국 내 2nm급 파운드리의 상징적 마일스톤.</a:t>
+              <a:t>INTC · 인텔 18A(Arizona)는 이미 HVM(대량생산) — 미국 내 2nm급 파운드리의 상징적 마일스톤.</a:t>
             </a:r>
           </a:p>
           <a:p>
             <a:pPr>
               <a:lnSpc>
-                <a:spcPct val="115000"/>
+                <a:spcPct val="125000"/>
               </a:lnSpc>
               <a:spcAft>
                 <a:spcPts val="1000"/>
@@ -14043,7 +14187,7 @@
               </a:defRPr>
             </a:pPr>
             <a:r>
-              <a:t>Secure Enclave: Intel에 DoD $3B — 군·정보기관용 보안 칩 공급망.</a:t>
+              <a:t>Secure Enclave: INTC · 인텔에 DoD $3B — 군·정보기관용 보안 칩 공급망.</a:t>
             </a:r>
           </a:p>
         </p:txBody>
@@ -14243,7 +14387,7 @@
         </p:nvGraphicFramePr>
         <p:xfrm>
           <a:off x="365760" y="1143000"/>
-          <a:ext cx="6309360" cy="2231136"/>
+          <a:ext cx="6309360" cy="2916936"/>
         </p:xfrm>
         <a:graphic>
           <a:graphicData uri="http://schemas.openxmlformats.org/drawingml/2006/table">
@@ -14252,26 +14396,26 @@
                 <a:tableStyleId>{5C22544A-7EE6-4342-B048-85BDC9FD1C3A}</a:tableStyleId>
               </a:tblPr>
               <a:tblGrid>
-                <a:gridCol w="822960"/>
-                <a:gridCol w="1188720"/>
+                <a:gridCol w="1005840"/>
+                <a:gridCol w="1097280"/>
                 <a:gridCol w="2011680"/>
-                <a:gridCol w="2286000"/>
+                <a:gridCol w="2194560"/>
               </a:tblGrid>
-              <a:tr h="318733">
+              <a:tr h="416705">
                 <a:tc>
                   <a:txBody>
                     <a:bodyPr/>
                     <a:lstStyle/>
                     <a:p>
                       <a:pPr>
-                        <a:defRPr b="1" sz="900">
+                        <a:defRPr b="1" sz="1100">
                           <a:solidFill>
                             <a:srgbClr val="FFFFFF"/>
                           </a:solidFill>
                         </a:defRPr>
                       </a:pPr>
                       <a:r>
-                        <a:t>기업</a:t>
+                        <a:t>종목</a:t>
                       </a:r>
                     </a:p>
                   </a:txBody>
@@ -14287,7 +14431,7 @@
                     <a:lstStyle/>
                     <a:p>
                       <a:pPr>
-                        <a:defRPr b="1" sz="900">
+                        <a:defRPr b="1" sz="1100">
                           <a:solidFill>
                             <a:srgbClr val="FFFFFF"/>
                           </a:solidFill>
@@ -14310,7 +14454,7 @@
                     <a:lstStyle/>
                     <a:p>
                       <a:pPr>
-                        <a:defRPr b="1" sz="900">
+                        <a:defRPr b="1" sz="1100">
                           <a:solidFill>
                             <a:srgbClr val="FFFFFF"/>
                           </a:solidFill>
@@ -14333,7 +14477,7 @@
                     <a:lstStyle/>
                     <a:p>
                       <a:pPr>
-                        <a:defRPr b="1" sz="900">
+                        <a:defRPr b="1" sz="1100">
                           <a:solidFill>
                             <a:srgbClr val="FFFFFF"/>
                           </a:solidFill>
@@ -14351,25 +14495,37 @@
                   </a:tcPr>
                 </a:tc>
               </a:tr>
-              <a:tr h="318733">
+              <a:tr h="416705">
                 <a:tc>
                   <a:txBody>
                     <a:bodyPr/>
                     <a:lstStyle/>
                     <a:p>
                       <a:pPr>
-                        <a:defRPr sz="800">
+                        <a:defRPr b="1" sz="1100">
                           <a:solidFill>
-                            <a:srgbClr val="334155"/>
+                            <a:srgbClr val="0F172A"/>
                           </a:solidFill>
                         </a:defRPr>
                       </a:pPr>
                       <a:r>
-                        <a:t>Intel</a:t>
+                        <a:t>INTC</a:t>
+                      </a:r>
+                    </a:p>
+                    <a:p>
+                      <a:pPr>
+                        <a:defRPr sz="1000">
+                          <a:solidFill>
+                            <a:srgbClr val="94A3B8"/>
+                          </a:solidFill>
+                        </a:defRPr>
+                      </a:pPr>
+                      <a:r>
+                        <a:t>인텔</a:t>
                       </a:r>
                     </a:p>
                   </a:txBody>
-                  <a:tcPr>
+                  <a:tcPr marL="54864" marR="36576" marT="36576" marB="36576">
                     <a:solidFill>
                       <a:srgbClr val="F8FAFC"/>
                     </a:solidFill>
@@ -14381,7 +14537,7 @@
                     <a:lstStyle/>
                     <a:p>
                       <a:pPr>
-                        <a:defRPr sz="800">
+                        <a:defRPr sz="1000">
                           <a:solidFill>
                             <a:srgbClr val="334155"/>
                           </a:solidFill>
@@ -14392,7 +14548,7 @@
                       </a:r>
                     </a:p>
                   </a:txBody>
-                  <a:tcPr>
+                  <a:tcPr marL="54864" marR="36576" marT="36576" marB="36576">
                     <a:solidFill>
                       <a:srgbClr val="F8FAFC"/>
                     </a:solidFill>
@@ -14404,7 +14560,7 @@
                     <a:lstStyle/>
                     <a:p>
                       <a:pPr>
-                        <a:defRPr sz="800">
+                        <a:defRPr sz="1000">
                           <a:solidFill>
                             <a:srgbClr val="334155"/>
                           </a:solidFill>
@@ -14415,7 +14571,7 @@
                       </a:r>
                     </a:p>
                   </a:txBody>
-                  <a:tcPr>
+                  <a:tcPr marL="54864" marR="36576" marT="36576" marB="36576">
                     <a:solidFill>
                       <a:srgbClr val="F8FAFC"/>
                     </a:solidFill>
@@ -14427,7 +14583,7 @@
                     <a:lstStyle/>
                     <a:p>
                       <a:pPr>
-                        <a:defRPr sz="800">
+                        <a:defRPr sz="1000">
                           <a:solidFill>
                             <a:srgbClr val="334155"/>
                           </a:solidFill>
@@ -14438,23 +14594,35 @@
                       </a:r>
                     </a:p>
                   </a:txBody>
-                  <a:tcPr>
+                  <a:tcPr marL="54864" marR="36576" marT="36576" marB="36576">
                     <a:solidFill>
                       <a:srgbClr val="F8FAFC"/>
                     </a:solidFill>
                   </a:tcPr>
                 </a:tc>
               </a:tr>
-              <a:tr h="318733">
+              <a:tr h="416705">
                 <a:tc>
                   <a:txBody>
                     <a:bodyPr/>
                     <a:lstStyle/>
                     <a:p>
                       <a:pPr>
-                        <a:defRPr sz="800">
+                        <a:defRPr b="1" sz="1100">
                           <a:solidFill>
-                            <a:srgbClr val="334155"/>
+                            <a:srgbClr val="0F172A"/>
+                          </a:solidFill>
+                        </a:defRPr>
+                      </a:pPr>
+                      <a:r>
+                        <a:t>TSM</a:t>
+                      </a:r>
+                    </a:p>
+                    <a:p>
+                      <a:pPr>
+                        <a:defRPr sz="1000">
+                          <a:solidFill>
+                            <a:srgbClr val="94A3B8"/>
                           </a:solidFill>
                         </a:defRPr>
                       </a:pPr>
@@ -14463,7 +14631,7 @@
                       </a:r>
                     </a:p>
                   </a:txBody>
-                  <a:tcPr>
+                  <a:tcPr marL="54864" marR="36576" marT="36576" marB="36576">
                     <a:solidFill>
                       <a:srgbClr val="FFFFFF"/>
                     </a:solidFill>
@@ -14475,7 +14643,7 @@
                     <a:lstStyle/>
                     <a:p>
                       <a:pPr>
-                        <a:defRPr sz="800">
+                        <a:defRPr sz="1000">
                           <a:solidFill>
                             <a:srgbClr val="334155"/>
                           </a:solidFill>
@@ -14486,7 +14654,7 @@
                       </a:r>
                     </a:p>
                   </a:txBody>
-                  <a:tcPr>
+                  <a:tcPr marL="54864" marR="36576" marT="36576" marB="36576">
                     <a:solidFill>
                       <a:srgbClr val="FFFFFF"/>
                     </a:solidFill>
@@ -14498,7 +14666,7 @@
                     <a:lstStyle/>
                     <a:p>
                       <a:pPr>
-                        <a:defRPr sz="800">
+                        <a:defRPr sz="1000">
                           <a:solidFill>
                             <a:srgbClr val="334155"/>
                           </a:solidFill>
@@ -14509,7 +14677,7 @@
                       </a:r>
                     </a:p>
                   </a:txBody>
-                  <a:tcPr>
+                  <a:tcPr marL="54864" marR="36576" marT="36576" marB="36576">
                     <a:solidFill>
                       <a:srgbClr val="FFFFFF"/>
                     </a:solidFill>
@@ -14521,7 +14689,7 @@
                     <a:lstStyle/>
                     <a:p>
                       <a:pPr>
-                        <a:defRPr sz="800">
+                        <a:defRPr sz="1000">
                           <a:solidFill>
                             <a:srgbClr val="334155"/>
                           </a:solidFill>
@@ -14532,32 +14700,32 @@
                       </a:r>
                     </a:p>
                   </a:txBody>
-                  <a:tcPr>
+                  <a:tcPr marL="54864" marR="36576" marT="36576" marB="36576">
                     <a:solidFill>
                       <a:srgbClr val="FFFFFF"/>
                     </a:solidFill>
                   </a:tcPr>
                 </a:tc>
               </a:tr>
-              <a:tr h="318733">
+              <a:tr h="416705">
                 <a:tc>
                   <a:txBody>
                     <a:bodyPr/>
                     <a:lstStyle/>
                     <a:p>
                       <a:pPr>
-                        <a:defRPr sz="800">
+                        <a:defRPr sz="1000">
                           <a:solidFill>
                             <a:srgbClr val="334155"/>
                           </a:solidFill>
                         </a:defRPr>
                       </a:pPr>
                       <a:r>
-                        <a:t>Samsung</a:t>
+                        <a:t>삼성전자</a:t>
                       </a:r>
                     </a:p>
                   </a:txBody>
-                  <a:tcPr>
+                  <a:tcPr marL="54864" marR="36576" marT="36576" marB="36576">
                     <a:solidFill>
                       <a:srgbClr val="F8FAFC"/>
                     </a:solidFill>
@@ -14569,7 +14737,7 @@
                     <a:lstStyle/>
                     <a:p>
                       <a:pPr>
-                        <a:defRPr sz="800">
+                        <a:defRPr sz="1000">
                           <a:solidFill>
                             <a:srgbClr val="334155"/>
                           </a:solidFill>
@@ -14580,7 +14748,7 @@
                       </a:r>
                     </a:p>
                   </a:txBody>
-                  <a:tcPr>
+                  <a:tcPr marL="54864" marR="36576" marT="36576" marB="36576">
                     <a:solidFill>
                       <a:srgbClr val="F8FAFC"/>
                     </a:solidFill>
@@ -14592,7 +14760,7 @@
                     <a:lstStyle/>
                     <a:p>
                       <a:pPr>
-                        <a:defRPr sz="800">
+                        <a:defRPr sz="1000">
                           <a:solidFill>
                             <a:srgbClr val="334155"/>
                           </a:solidFill>
@@ -14603,7 +14771,7 @@
                       </a:r>
                     </a:p>
                   </a:txBody>
-                  <a:tcPr>
+                  <a:tcPr marL="54864" marR="36576" marT="36576" marB="36576">
                     <a:solidFill>
                       <a:srgbClr val="F8FAFC"/>
                     </a:solidFill>
@@ -14615,7 +14783,7 @@
                     <a:lstStyle/>
                     <a:p>
                       <a:pPr>
-                        <a:defRPr sz="800">
+                        <a:defRPr sz="1000">
                           <a:solidFill>
                             <a:srgbClr val="334155"/>
                           </a:solidFill>
@@ -14626,32 +14794,44 @@
                       </a:r>
                     </a:p>
                   </a:txBody>
-                  <a:tcPr>
+                  <a:tcPr marL="54864" marR="36576" marT="36576" marB="36576">
                     <a:solidFill>
                       <a:srgbClr val="F8FAFC"/>
                     </a:solidFill>
                   </a:tcPr>
                 </a:tc>
               </a:tr>
-              <a:tr h="318733">
+              <a:tr h="416705">
                 <a:tc>
                   <a:txBody>
                     <a:bodyPr/>
                     <a:lstStyle/>
                     <a:p>
                       <a:pPr>
-                        <a:defRPr sz="800">
+                        <a:defRPr b="1" sz="1100">
                           <a:solidFill>
-                            <a:srgbClr val="334155"/>
+                            <a:srgbClr val="0F172A"/>
                           </a:solidFill>
                         </a:defRPr>
                       </a:pPr>
                       <a:r>
-                        <a:t>Micron</a:t>
+                        <a:t>MU</a:t>
+                      </a:r>
+                    </a:p>
+                    <a:p>
+                      <a:pPr>
+                        <a:defRPr sz="1000">
+                          <a:solidFill>
+                            <a:srgbClr val="94A3B8"/>
+                          </a:solidFill>
+                        </a:defRPr>
+                      </a:pPr>
+                      <a:r>
+                        <a:t>마이크론</a:t>
                       </a:r>
                     </a:p>
                   </a:txBody>
-                  <a:tcPr>
+                  <a:tcPr marL="54864" marR="36576" marT="36576" marB="36576">
                     <a:solidFill>
                       <a:srgbClr val="FFFFFF"/>
                     </a:solidFill>
@@ -14663,7 +14843,7 @@
                     <a:lstStyle/>
                     <a:p>
                       <a:pPr>
-                        <a:defRPr sz="800">
+                        <a:defRPr sz="1000">
                           <a:solidFill>
                             <a:srgbClr val="334155"/>
                           </a:solidFill>
@@ -14674,7 +14854,7 @@
                       </a:r>
                     </a:p>
                   </a:txBody>
-                  <a:tcPr>
+                  <a:tcPr marL="54864" marR="36576" marT="36576" marB="36576">
                     <a:solidFill>
                       <a:srgbClr val="FFFFFF"/>
                     </a:solidFill>
@@ -14686,7 +14866,7 @@
                     <a:lstStyle/>
                     <a:p>
                       <a:pPr>
-                        <a:defRPr sz="800">
+                        <a:defRPr sz="1000">
                           <a:solidFill>
                             <a:srgbClr val="334155"/>
                           </a:solidFill>
@@ -14697,7 +14877,7 @@
                       </a:r>
                     </a:p>
                   </a:txBody>
-                  <a:tcPr>
+                  <a:tcPr marL="54864" marR="36576" marT="36576" marB="36576">
                     <a:solidFill>
                       <a:srgbClr val="FFFFFF"/>
                     </a:solidFill>
@@ -14709,7 +14889,7 @@
                     <a:lstStyle/>
                     <a:p>
                       <a:pPr>
-                        <a:defRPr sz="800">
+                        <a:defRPr sz="1000">
                           <a:solidFill>
                             <a:srgbClr val="334155"/>
                           </a:solidFill>
@@ -14720,23 +14900,23 @@
                       </a:r>
                     </a:p>
                   </a:txBody>
-                  <a:tcPr>
+                  <a:tcPr marL="54864" marR="36576" marT="36576" marB="36576">
                     <a:solidFill>
                       <a:srgbClr val="FFFFFF"/>
                     </a:solidFill>
                   </a:tcPr>
                 </a:tc>
               </a:tr>
-              <a:tr h="318733">
+              <a:tr h="416705">
                 <a:tc>
                   <a:txBody>
                     <a:bodyPr/>
                     <a:lstStyle/>
                     <a:p>
                       <a:pPr>
-                        <a:defRPr sz="800">
+                        <a:defRPr b="1" sz="1100">
                           <a:solidFill>
-                            <a:srgbClr val="334155"/>
+                            <a:srgbClr val="0F172A"/>
                           </a:solidFill>
                         </a:defRPr>
                       </a:pPr>
@@ -14744,8 +14924,20 @@
                         <a:t>AMAT</a:t>
                       </a:r>
                     </a:p>
+                    <a:p>
+                      <a:pPr>
+                        <a:defRPr sz="1000">
+                          <a:solidFill>
+                            <a:srgbClr val="94A3B8"/>
+                          </a:solidFill>
+                        </a:defRPr>
+                      </a:pPr>
+                      <a:r>
+                        <a:t>어플라이드 머티리얼즈</a:t>
+                      </a:r>
+                    </a:p>
                   </a:txBody>
-                  <a:tcPr>
+                  <a:tcPr marL="54864" marR="36576" marT="36576" marB="36576">
                     <a:solidFill>
                       <a:srgbClr val="F8FAFC"/>
                     </a:solidFill>
@@ -14757,7 +14949,7 @@
                     <a:lstStyle/>
                     <a:p>
                       <a:pPr>
-                        <a:defRPr sz="800">
+                        <a:defRPr sz="1000">
                           <a:solidFill>
                             <a:srgbClr val="334155"/>
                           </a:solidFill>
@@ -14768,7 +14960,7 @@
                       </a:r>
                     </a:p>
                   </a:txBody>
-                  <a:tcPr>
+                  <a:tcPr marL="54864" marR="36576" marT="36576" marB="36576">
                     <a:solidFill>
                       <a:srgbClr val="F8FAFC"/>
                     </a:solidFill>
@@ -14780,7 +14972,7 @@
                     <a:lstStyle/>
                     <a:p>
                       <a:pPr>
-                        <a:defRPr sz="800">
+                        <a:defRPr sz="1000">
                           <a:solidFill>
                             <a:srgbClr val="334155"/>
                           </a:solidFill>
@@ -14791,7 +14983,7 @@
                       </a:r>
                     </a:p>
                   </a:txBody>
-                  <a:tcPr>
+                  <a:tcPr marL="54864" marR="36576" marT="36576" marB="36576">
                     <a:solidFill>
                       <a:srgbClr val="F8FAFC"/>
                     </a:solidFill>
@@ -14803,7 +14995,7 @@
                     <a:lstStyle/>
                     <a:p>
                       <a:pPr>
-                        <a:defRPr sz="800">
+                        <a:defRPr sz="1000">
                           <a:solidFill>
                             <a:srgbClr val="334155"/>
                           </a:solidFill>
@@ -14814,23 +15006,35 @@
                       </a:r>
                     </a:p>
                   </a:txBody>
-                  <a:tcPr>
+                  <a:tcPr marL="54864" marR="36576" marT="36576" marB="36576">
                     <a:solidFill>
                       <a:srgbClr val="F8FAFC"/>
                     </a:solidFill>
                   </a:tcPr>
                 </a:tc>
               </a:tr>
-              <a:tr h="318738">
+              <a:tr h="416706">
                 <a:tc>
                   <a:txBody>
                     <a:bodyPr/>
                     <a:lstStyle/>
                     <a:p>
                       <a:pPr>
-                        <a:defRPr sz="800">
+                        <a:defRPr b="1" sz="1100">
                           <a:solidFill>
-                            <a:srgbClr val="334155"/>
+                            <a:srgbClr val="0F172A"/>
+                          </a:solidFill>
+                        </a:defRPr>
+                      </a:pPr>
+                      <a:r>
+                        <a:t>ASML</a:t>
+                      </a:r>
+                    </a:p>
+                    <a:p>
+                      <a:pPr>
+                        <a:defRPr sz="1000">
+                          <a:solidFill>
+                            <a:srgbClr val="94A3B8"/>
                           </a:solidFill>
                         </a:defRPr>
                       </a:pPr>
@@ -14839,7 +15043,7 @@
                       </a:r>
                     </a:p>
                   </a:txBody>
-                  <a:tcPr>
+                  <a:tcPr marL="54864" marR="36576" marT="36576" marB="36576">
                     <a:solidFill>
                       <a:srgbClr val="FFFFFF"/>
                     </a:solidFill>
@@ -14851,7 +15055,7 @@
                     <a:lstStyle/>
                     <a:p>
                       <a:pPr>
-                        <a:defRPr sz="800">
+                        <a:defRPr sz="1000">
                           <a:solidFill>
                             <a:srgbClr val="334155"/>
                           </a:solidFill>
@@ -14862,7 +15066,7 @@
                       </a:r>
                     </a:p>
                   </a:txBody>
-                  <a:tcPr>
+                  <a:tcPr marL="54864" marR="36576" marT="36576" marB="36576">
                     <a:solidFill>
                       <a:srgbClr val="FFFFFF"/>
                     </a:solidFill>
@@ -14874,7 +15078,7 @@
                     <a:lstStyle/>
                     <a:p>
                       <a:pPr>
-                        <a:defRPr sz="800">
+                        <a:defRPr sz="1000">
                           <a:solidFill>
                             <a:srgbClr val="334155"/>
                           </a:solidFill>
@@ -14885,7 +15089,7 @@
                       </a:r>
                     </a:p>
                   </a:txBody>
-                  <a:tcPr>
+                  <a:tcPr marL="54864" marR="36576" marT="36576" marB="36576">
                     <a:solidFill>
                       <a:srgbClr val="FFFFFF"/>
                     </a:solidFill>
@@ -14897,7 +15101,7 @@
                     <a:lstStyle/>
                     <a:p>
                       <a:pPr>
-                        <a:defRPr sz="800">
+                        <a:defRPr sz="1000">
                           <a:solidFill>
                             <a:srgbClr val="334155"/>
                           </a:solidFill>
@@ -14908,7 +15112,7 @@
                       </a:r>
                     </a:p>
                   </a:txBody>
-                  <a:tcPr>
+                  <a:tcPr marL="54864" marR="36576" marT="36576" marB="36576">
                     <a:solidFill>
                       <a:srgbClr val="FFFFFF"/>
                     </a:solidFill>
@@ -15363,7 +15567,7 @@
           <a:p>
             <a:pPr>
               <a:lnSpc>
-                <a:spcPct val="115000"/>
+                <a:spcPct val="125000"/>
               </a:lnSpc>
               <a:spcAft>
                 <a:spcPts val="1200"/>
@@ -15381,7 +15585,7 @@
           <a:p>
             <a:pPr>
               <a:lnSpc>
-                <a:spcPct val="115000"/>
+                <a:spcPct val="125000"/>
               </a:lnSpc>
               <a:spcAft>
                 <a:spcPts val="1200"/>
@@ -15399,7 +15603,7 @@
           <a:p>
             <a:pPr>
               <a:lnSpc>
-                <a:spcPct val="115000"/>
+                <a:spcPct val="125000"/>
               </a:lnSpc>
               <a:spcAft>
                 <a:spcPts val="1200"/>
@@ -15411,13 +15615,13 @@
               </a:defRPr>
             </a:pPr>
             <a:r>
-              <a:t>양자 '하드웨어' 투자(IonQ 등)는 2028 FTQC(장애허용 양자컴퓨터) 전후가 관건이고, PQC 투자(PANW, CRWD 등)는 지금부터 5년간 매출이 발생합니다.</a:t>
+              <a:t>양자 '하드웨어' 투자(IONQ · 아이온큐 등)는 2028 FTQC(장애허용 양자컴퓨터) 전후가 관건이고, PQC 투자(PANW(팔로알토), CRWD(크라우드스트라이크) 등)는 지금부터 5년간 매출이 발생합니다.</a:t>
             </a:r>
           </a:p>
           <a:p>
             <a:pPr>
               <a:lnSpc>
-                <a:spcPct val="115000"/>
+                <a:spcPct val="125000"/>
               </a:lnSpc>
               <a:spcAft>
                 <a:spcPts val="1200"/>
@@ -15643,7 +15847,7 @@
           <a:p>
             <a:pPr>
               <a:lnSpc>
-                <a:spcPct val="115000"/>
+                <a:spcPct val="125000"/>
               </a:lnSpc>
               <a:spcAft>
                 <a:spcPts val="1200"/>
@@ -15661,7 +15865,7 @@
           <a:p>
             <a:pPr>
               <a:lnSpc>
-                <a:spcPct val="115000"/>
+                <a:spcPct val="125000"/>
               </a:lnSpc>
               <a:spcAft>
                 <a:spcPts val="1200"/>
@@ -15679,7 +15883,7 @@
           <a:p>
             <a:pPr>
               <a:lnSpc>
-                <a:spcPct val="115000"/>
+                <a:spcPct val="125000"/>
               </a:lnSpc>
               <a:spcAft>
                 <a:spcPts val="1200"/>
@@ -15697,7 +15901,7 @@
           <a:p>
             <a:pPr>
               <a:lnSpc>
-                <a:spcPct val="115000"/>
+                <a:spcPct val="125000"/>
               </a:lnSpc>
               <a:spcAft>
                 <a:spcPts val="1200"/>
@@ -15710,6 +15914,24 @@
             </a:pPr>
             <a:r>
               <a:t>★ Rating은 기술·수요·정부 지원·실현 가능성을 종합한 상대 평가이며, 매수 추천이 아닙니다.</a:t>
+            </a:r>
+          </a:p>
+          <a:p>
+            <a:pPr>
+              <a:lnSpc>
+                <a:spcPct val="125000"/>
+              </a:lnSpc>
+              <a:spcAft>
+                <a:spcPts val="1200"/>
+              </a:spcAft>
+              <a:defRPr sz="1300">
+                <a:solidFill>
+                  <a:srgbClr val="334155"/>
+                </a:solidFill>
+              </a:defRPr>
+            </a:pPr>
+            <a:r>
+              <a:t>종목 표기: NVDA(엔비디아) · 엔비디아 형식 — 앞은 티커(미국 주식 코드), 뒤는 한글 회사명입니다.</a:t>
             </a:r>
           </a:p>
         </p:txBody>
@@ -16032,7 +16254,7 @@
               </a:defRPr>
             </a:pPr>
             <a:r>
-              <a:t>2025–27: 파일럿·클라우드 접근·정부 R&amp;D — 매출은 작지만 CAGR 40%+</a:t>
+              <a:t>2025–27: 파일럿·클라우드 접근·정부 R&amp;D(도미니언 에너지) — 매출은 작지만 CAGR 40%+</a:t>
             </a:r>
           </a:p>
           <a:p>
@@ -16409,7 +16631,7 @@
               </a:defRPr>
             </a:pPr>
             <a:r>
-              <a:t>IonQ = 상장 pure-play, 매출·RPO로 검증 가능</a:t>
+              <a:t>IONQ · 아이온큐 = 상장 pure-play, 매출·RPO로 검증 가능</a:t>
             </a:r>
           </a:p>
           <a:p>
@@ -16424,7 +16646,7 @@
               </a:defRPr>
             </a:pPr>
             <a:r>
-              <a:t>Google = Alphabet 내부, 연구·QEC에서 선행, 상용 매출은 작음</a:t>
+              <a:t>GOOGL · 알파벳 = GOOGL · 알파벳 내부, 연구·QEC에서 선행, 상용 매출은 작음</a:t>
             </a:r>
           </a:p>
           <a:p>
@@ -16663,7 +16885,7 @@
         </p:nvGraphicFramePr>
         <p:xfrm>
           <a:off x="365760" y="1143000"/>
-          <a:ext cx="7315200" cy="1645920"/>
+          <a:ext cx="7223760" cy="1874519"/>
         </p:xfrm>
         <a:graphic>
           <a:graphicData uri="http://schemas.openxmlformats.org/drawingml/2006/table">
@@ -16672,19 +16894,19 @@
                 <a:tableStyleId>{5C22544A-7EE6-4342-B048-85BDC9FD1C3A}</a:tableStyleId>
               </a:tblPr>
               <a:tblGrid>
-                <a:gridCol w="1005840"/>
-                <a:gridCol w="2011680"/>
-                <a:gridCol w="2286000"/>
-                <a:gridCol w="2011680"/>
+                <a:gridCol w="914400"/>
+                <a:gridCol w="2377440"/>
+                <a:gridCol w="2103120"/>
+                <a:gridCol w="1828800"/>
               </a:tblGrid>
-              <a:tr h="329184">
+              <a:tr h="374903">
                 <a:tc>
                   <a:txBody>
                     <a:bodyPr/>
                     <a:lstStyle/>
                     <a:p>
                       <a:pPr>
-                        <a:defRPr b="1" sz="900">
+                        <a:defRPr b="1" sz="1100">
                           <a:solidFill>
                             <a:srgbClr val="FFFFFF"/>
                           </a:solidFill>
@@ -16707,14 +16929,14 @@
                     <a:lstStyle/>
                     <a:p>
                       <a:pPr>
-                        <a:defRPr b="1" sz="900">
+                        <a:defRPr b="1" sz="1100">
                           <a:solidFill>
                             <a:srgbClr val="FFFFFF"/>
                           </a:solidFill>
                         </a:defRPr>
                       </a:pPr>
                       <a:r>
-                        <a:t>대표 티커</a:t>
+                        <a:t>대표 종목</a:t>
                       </a:r>
                     </a:p>
                   </a:txBody>
@@ -16730,7 +16952,7 @@
                     <a:lstStyle/>
                     <a:p>
                       <a:pPr>
-                        <a:defRPr b="1" sz="900">
+                        <a:defRPr b="1" sz="1100">
                           <a:solidFill>
                             <a:srgbClr val="FFFFFF"/>
                           </a:solidFill>
@@ -16753,7 +16975,7 @@
                     <a:lstStyle/>
                     <a:p>
                       <a:pPr>
-                        <a:defRPr b="1" sz="900">
+                        <a:defRPr b="1" sz="1100">
                           <a:solidFill>
                             <a:srgbClr val="FFFFFF"/>
                           </a:solidFill>
@@ -16771,14 +16993,14 @@
                   </a:tcPr>
                 </a:tc>
               </a:tr>
-              <a:tr h="329184">
+              <a:tr h="374903">
                 <a:tc>
                   <a:txBody>
                     <a:bodyPr/>
                     <a:lstStyle/>
                     <a:p>
                       <a:pPr>
-                        <a:defRPr sz="800">
+                        <a:defRPr sz="1000">
                           <a:solidFill>
                             <a:srgbClr val="334155"/>
                           </a:solidFill>
@@ -16789,7 +17011,7 @@
                       </a:r>
                     </a:p>
                   </a:txBody>
-                  <a:tcPr>
+                  <a:tcPr marL="54864" marR="36576" marT="36576" marB="36576">
                     <a:solidFill>
                       <a:srgbClr val="F8FAFC"/>
                     </a:solidFill>
@@ -16801,18 +17023,42 @@
                     <a:lstStyle/>
                     <a:p>
                       <a:pPr>
-                        <a:defRPr sz="800">
+                        <a:defRPr sz="1000">
                           <a:solidFill>
                             <a:srgbClr val="334155"/>
                           </a:solidFill>
                         </a:defRPr>
                       </a:pPr>
                       <a:r>
-                        <a:t>IONQ RGTI QBTS</a:t>
+                        <a:t>IONQ(아이온큐) · 아이온큐</a:t>
+                      </a:r>
+                    </a:p>
+                    <a:p>
+                      <a:pPr>
+                        <a:defRPr sz="1000">
+                          <a:solidFill>
+                            <a:srgbClr val="334155"/>
+                          </a:solidFill>
+                        </a:defRPr>
+                      </a:pPr>
+                      <a:r>
+                        <a:t>RGTI(리게티) · 리게티</a:t>
+                      </a:r>
+                    </a:p>
+                    <a:p>
+                      <a:pPr>
+                        <a:defRPr sz="1000">
+                          <a:solidFill>
+                            <a:srgbClr val="334155"/>
+                          </a:solidFill>
+                        </a:defRPr>
+                      </a:pPr>
+                      <a:r>
+                        <a:t>QBTS(디웨이브) · 디웨이브</a:t>
                       </a:r>
                     </a:p>
                   </a:txBody>
-                  <a:tcPr>
+                  <a:tcPr marL="54864" marR="36576" marT="36576" marB="36576">
                     <a:solidFill>
                       <a:srgbClr val="F8FAFC"/>
                     </a:solidFill>
@@ -16824,7 +17070,7 @@
                     <a:lstStyle/>
                     <a:p>
                       <a:pPr>
-                        <a:defRPr sz="800">
+                        <a:defRPr sz="1000">
                           <a:solidFill>
                             <a:srgbClr val="334155"/>
                           </a:solidFill>
@@ -16835,7 +17081,7 @@
                       </a:r>
                     </a:p>
                   </a:txBody>
-                  <a:tcPr>
+                  <a:tcPr marL="54864" marR="36576" marT="36576" marB="36576">
                     <a:solidFill>
                       <a:srgbClr val="F8FAFC"/>
                     </a:solidFill>
@@ -16847,7 +17093,7 @@
                     <a:lstStyle/>
                     <a:p>
                       <a:pPr>
-                        <a:defRPr sz="800">
+                        <a:defRPr sz="1000">
                           <a:solidFill>
                             <a:srgbClr val="334155"/>
                           </a:solidFill>
@@ -16858,21 +17104,21 @@
                       </a:r>
                     </a:p>
                   </a:txBody>
-                  <a:tcPr>
+                  <a:tcPr marL="54864" marR="36576" marT="36576" marB="36576">
                     <a:solidFill>
                       <a:srgbClr val="F8FAFC"/>
                     </a:solidFill>
                   </a:tcPr>
                 </a:tc>
               </a:tr>
-              <a:tr h="329184">
+              <a:tr h="374903">
                 <a:tc>
                   <a:txBody>
                     <a:bodyPr/>
                     <a:lstStyle/>
                     <a:p>
                       <a:pPr>
-                        <a:defRPr sz="800">
+                        <a:defRPr sz="1000">
                           <a:solidFill>
                             <a:srgbClr val="334155"/>
                           </a:solidFill>
@@ -16883,7 +17129,7 @@
                       </a:r>
                     </a:p>
                   </a:txBody>
-                  <a:tcPr>
+                  <a:tcPr marL="54864" marR="36576" marT="36576" marB="36576">
                     <a:solidFill>
                       <a:srgbClr val="FFFFFF"/>
                     </a:solidFill>
@@ -16895,18 +17141,42 @@
                     <a:lstStyle/>
                     <a:p>
                       <a:pPr>
-                        <a:defRPr sz="800">
+                        <a:defRPr sz="1000">
                           <a:solidFill>
                             <a:srgbClr val="334155"/>
                           </a:solidFill>
                         </a:defRPr>
                       </a:pPr>
                       <a:r>
-                        <a:t>IBM GOOGL MSFT</a:t>
+                        <a:t>IBM(IBM) · IBM(IBM)</a:t>
+                      </a:r>
+                    </a:p>
+                    <a:p>
+                      <a:pPr>
+                        <a:defRPr sz="1000">
+                          <a:solidFill>
+                            <a:srgbClr val="334155"/>
+                          </a:solidFill>
+                        </a:defRPr>
+                      </a:pPr>
+                      <a:r>
+                        <a:t>GOOGL(알파벳(구글)) · 알파벳(구글)</a:t>
+                      </a:r>
+                    </a:p>
+                    <a:p>
+                      <a:pPr>
+                        <a:defRPr sz="1000">
+                          <a:solidFill>
+                            <a:srgbClr val="334155"/>
+                          </a:solidFill>
+                        </a:defRPr>
+                      </a:pPr>
+                      <a:r>
+                        <a:t>MSFT(마이크로소프트) · 마이크로소프트</a:t>
                       </a:r>
                     </a:p>
                   </a:txBody>
-                  <a:tcPr>
+                  <a:tcPr marL="54864" marR="36576" marT="36576" marB="36576">
                     <a:solidFill>
                       <a:srgbClr val="FFFFFF"/>
                     </a:solidFill>
@@ -16918,7 +17188,7 @@
                     <a:lstStyle/>
                     <a:p>
                       <a:pPr>
-                        <a:defRPr sz="800">
+                        <a:defRPr sz="1000">
                           <a:solidFill>
                             <a:srgbClr val="334155"/>
                           </a:solidFill>
@@ -16929,7 +17199,7 @@
                       </a:r>
                     </a:p>
                   </a:txBody>
-                  <a:tcPr>
+                  <a:tcPr marL="54864" marR="36576" marT="36576" marB="36576">
                     <a:solidFill>
                       <a:srgbClr val="FFFFFF"/>
                     </a:solidFill>
@@ -16941,7 +17211,7 @@
                     <a:lstStyle/>
                     <a:p>
                       <a:pPr>
-                        <a:defRPr sz="800">
+                        <a:defRPr sz="1000">
                           <a:solidFill>
                             <a:srgbClr val="334155"/>
                           </a:solidFill>
@@ -16952,21 +17222,21 @@
                       </a:r>
                     </a:p>
                   </a:txBody>
-                  <a:tcPr>
+                  <a:tcPr marL="54864" marR="36576" marT="36576" marB="36576">
                     <a:solidFill>
                       <a:srgbClr val="FFFFFF"/>
                     </a:solidFill>
                   </a:tcPr>
                 </a:tc>
               </a:tr>
-              <a:tr h="329184">
+              <a:tr h="374903">
                 <a:tc>
                   <a:txBody>
                     <a:bodyPr/>
                     <a:lstStyle/>
                     <a:p>
                       <a:pPr>
-                        <a:defRPr sz="800">
+                        <a:defRPr sz="1000">
                           <a:solidFill>
                             <a:srgbClr val="334155"/>
                           </a:solidFill>
@@ -16977,7 +17247,7 @@
                       </a:r>
                     </a:p>
                   </a:txBody>
-                  <a:tcPr>
+                  <a:tcPr marL="54864" marR="36576" marT="36576" marB="36576">
                     <a:solidFill>
                       <a:srgbClr val="F8FAFC"/>
                     </a:solidFill>
@@ -16989,18 +17259,54 @@
                     <a:lstStyle/>
                     <a:p>
                       <a:pPr>
-                        <a:defRPr sz="800">
+                        <a:defRPr sz="1000">
                           <a:solidFill>
                             <a:srgbClr val="334155"/>
                           </a:solidFill>
                         </a:defRPr>
                       </a:pPr>
                       <a:r>
-                        <a:t>PANW CRWD NET ZS</a:t>
+                        <a:t>PANW(팔로알토) · 팔로알토</a:t>
+                      </a:r>
+                    </a:p>
+                    <a:p>
+                      <a:pPr>
+                        <a:defRPr sz="1000">
+                          <a:solidFill>
+                            <a:srgbClr val="334155"/>
+                          </a:solidFill>
+                        </a:defRPr>
+                      </a:pPr>
+                      <a:r>
+                        <a:t>CRWD(크라우드스트라이크) · 크라우드스트라이크</a:t>
+                      </a:r>
+                    </a:p>
+                    <a:p>
+                      <a:pPr>
+                        <a:defRPr sz="1000">
+                          <a:solidFill>
+                            <a:srgbClr val="334155"/>
+                          </a:solidFill>
+                        </a:defRPr>
+                      </a:pPr>
+                      <a:r>
+                        <a:t>NET(클라우드플레어) · 클라우드플레어</a:t>
+                      </a:r>
+                    </a:p>
+                    <a:p>
+                      <a:pPr>
+                        <a:defRPr sz="1000">
+                          <a:solidFill>
+                            <a:srgbClr val="334155"/>
+                          </a:solidFill>
+                        </a:defRPr>
+                      </a:pPr>
+                      <a:r>
+                        <a:t>ZS(지스케일러) · 지스케일러</a:t>
                       </a:r>
                     </a:p>
                   </a:txBody>
-                  <a:tcPr>
+                  <a:tcPr marL="54864" marR="36576" marT="36576" marB="36576">
                     <a:solidFill>
                       <a:srgbClr val="F8FAFC"/>
                     </a:solidFill>
@@ -17012,7 +17318,7 @@
                     <a:lstStyle/>
                     <a:p>
                       <a:pPr>
-                        <a:defRPr sz="800">
+                        <a:defRPr sz="1000">
                           <a:solidFill>
                             <a:srgbClr val="334155"/>
                           </a:solidFill>
@@ -17023,7 +17329,7 @@
                       </a:r>
                     </a:p>
                   </a:txBody>
-                  <a:tcPr>
+                  <a:tcPr marL="54864" marR="36576" marT="36576" marB="36576">
                     <a:solidFill>
                       <a:srgbClr val="F8FAFC"/>
                     </a:solidFill>
@@ -17035,7 +17341,7 @@
                     <a:lstStyle/>
                     <a:p>
                       <a:pPr>
-                        <a:defRPr sz="800">
+                        <a:defRPr sz="1000">
                           <a:solidFill>
                             <a:srgbClr val="334155"/>
                           </a:solidFill>
@@ -17046,21 +17352,21 @@
                       </a:r>
                     </a:p>
                   </a:txBody>
-                  <a:tcPr>
+                  <a:tcPr marL="54864" marR="36576" marT="36576" marB="36576">
                     <a:solidFill>
                       <a:srgbClr val="F8FAFC"/>
                     </a:solidFill>
                   </a:tcPr>
                 </a:tc>
               </a:tr>
-              <a:tr h="329184">
+              <a:tr h="374907">
                 <a:tc>
                   <a:txBody>
                     <a:bodyPr/>
                     <a:lstStyle/>
                     <a:p>
                       <a:pPr>
-                        <a:defRPr sz="800">
+                        <a:defRPr sz="1000">
                           <a:solidFill>
                             <a:srgbClr val="334155"/>
                           </a:solidFill>
@@ -17071,7 +17377,7 @@
                       </a:r>
                     </a:p>
                   </a:txBody>
-                  <a:tcPr>
+                  <a:tcPr marL="54864" marR="36576" marT="36576" marB="36576">
                     <a:solidFill>
                       <a:srgbClr val="FFFFFF"/>
                     </a:solidFill>
@@ -17083,18 +17389,42 @@
                     <a:lstStyle/>
                     <a:p>
                       <a:pPr>
-                        <a:defRPr sz="800">
+                        <a:defRPr sz="1000">
                           <a:solidFill>
                             <a:srgbClr val="334155"/>
                           </a:solidFill>
                         </a:defRPr>
                       </a:pPr>
                       <a:r>
-                        <a:t>LAES WKEY NXPI</a:t>
+                        <a:t>LAES(실스큐) · 실스큐</a:t>
+                      </a:r>
+                    </a:p>
+                    <a:p>
+                      <a:pPr>
+                        <a:defRPr sz="1000">
+                          <a:solidFill>
+                            <a:srgbClr val="334155"/>
+                          </a:solidFill>
+                        </a:defRPr>
+                      </a:pPr>
+                      <a:r>
+                        <a:t>WKEY(와이즈키) · 와이즈키</a:t>
+                      </a:r>
+                    </a:p>
+                    <a:p>
+                      <a:pPr>
+                        <a:defRPr sz="1000">
+                          <a:solidFill>
+                            <a:srgbClr val="334155"/>
+                          </a:solidFill>
+                        </a:defRPr>
+                      </a:pPr>
+                      <a:r>
+                        <a:t>NXPI(NXP) · NXP</a:t>
                       </a:r>
                     </a:p>
                   </a:txBody>
-                  <a:tcPr>
+                  <a:tcPr marL="54864" marR="36576" marT="36576" marB="36576">
                     <a:solidFill>
                       <a:srgbClr val="FFFFFF"/>
                     </a:solidFill>
@@ -17106,7 +17436,7 @@
                     <a:lstStyle/>
                     <a:p>
                       <a:pPr>
-                        <a:defRPr sz="800">
+                        <a:defRPr sz="1000">
                           <a:solidFill>
                             <a:srgbClr val="334155"/>
                           </a:solidFill>
@@ -17117,7 +17447,7 @@
                       </a:r>
                     </a:p>
                   </a:txBody>
-                  <a:tcPr>
+                  <a:tcPr marL="54864" marR="36576" marT="36576" marB="36576">
                     <a:solidFill>
                       <a:srgbClr val="FFFFFF"/>
                     </a:solidFill>
@@ -17129,7 +17459,7 @@
                     <a:lstStyle/>
                     <a:p>
                       <a:pPr>
-                        <a:defRPr sz="800">
+                        <a:defRPr sz="1000">
                           <a:solidFill>
                             <a:srgbClr val="334155"/>
                           </a:solidFill>
@@ -17140,7 +17470,7 @@
                       </a:r>
                     </a:p>
                   </a:txBody>
-                  <a:tcPr>
+                  <a:tcPr marL="54864" marR="36576" marT="36576" marB="36576">
                     <a:solidFill>
                       <a:srgbClr val="FFFFFF"/>
                     </a:solidFill>
@@ -17595,7 +17925,7 @@
           <a:p>
             <a:pPr>
               <a:lnSpc>
-                <a:spcPct val="115000"/>
+                <a:spcPct val="125000"/>
               </a:lnSpc>
               <a:spcAft>
                 <a:spcPts val="1200"/>
@@ -17607,13 +17937,13 @@
               </a:defRPr>
             </a:pPr>
             <a:r>
-              <a:t>1단계(지금): 창고·공장 — Amazon 75만 대+, Symbotic(Walmart), Fanuc·ABB 산업로봇에 AI 비전·경로계획 탑재.</a:t>
+              <a:t>1단계(지금): 창고·공장 — AMZN · 아마존 75만 대+, Symbotic(Walmart), Fanuc·ABB(ABB) 산업로봇에 AI 비전·경로계획 탑재.</a:t>
             </a:r>
           </a:p>
           <a:p>
             <a:pPr>
               <a:lnSpc>
-                <a:spcPct val="115000"/>
+                <a:spcPct val="125000"/>
               </a:lnSpc>
               <a:spcAft>
                 <a:spcPts val="1200"/>
@@ -17625,13 +17955,13 @@
               </a:defRPr>
             </a:pPr>
             <a:r>
-              <a:t>2단계(2026–28): 물류·검사·위험 작업 — 드론(AVAV), 수술로봇(ISRG)은 이미 수익화.</a:t>
+              <a:t>2단계(2026–28): 물류·검사·위험 작업 — 드론(AVAV(에어로바이론먼트)), 수술로봇(ISRG(인튜이티브 서지컬))은 이미 수익화.</a:t>
             </a:r>
           </a:p>
           <a:p>
             <a:pPr>
               <a:lnSpc>
-                <a:spcPct val="115000"/>
+                <a:spcPct val="125000"/>
               </a:lnSpc>
               <a:spcAft>
                 <a:spcPts val="1200"/>
@@ -17643,13 +17973,13 @@
               </a:defRPr>
             </a:pPr>
             <a:r>
-              <a:t>3단계(2028–32): 휴머노이드 — Tesla Optimus, Figure AI, Boston Dynamics Atlas. 아직 '매출'보다 '파일럿·생산속도'가 뉴스.</a:t>
+              <a:t>3단계(2028–32): 휴머노이드 — TSLA · 테슬라 Optimus, 피겨 AI(비상장), Boston Dynamics Atlas. 아직 '매출'보다 '파일럿·생산속도'가 뉴스.</a:t>
             </a:r>
           </a:p>
           <a:p>
             <a:pPr>
               <a:lnSpc>
-                <a:spcPct val="115000"/>
+                <a:spcPct val="125000"/>
               </a:lnSpc>
               <a:spcAft>
                 <a:spcPts val="1200"/>
@@ -17661,7 +17991,7 @@
               </a:defRPr>
             </a:pPr>
             <a:r>
-              <a:t>투자 현실: pure-play 휴머노이드 상장사는 거의 없음(TSLA, UBTECH). 부품·SI(NVDA, TER, CGNX)가 안전한 간접 노출.</a:t>
+              <a:t>투자 현실: pure-play 휴머노이드 상장사는 거의 없음(TSLA(테슬라), UBTECH). 부품·SI(NVDA(엔비디아), TER(테라다인), CGNX(코그넥스))가 안전한 간접 노출.</a:t>
             </a:r>
           </a:p>
         </p:txBody>
@@ -18415,7 +18745,7 @@
           <a:p>
             <a:pPr>
               <a:lnSpc>
-                <a:spcPct val="115000"/>
+                <a:spcPct val="125000"/>
               </a:lnSpc>
               <a:spcAft>
                 <a:spcPts val="1000"/>
@@ -18427,13 +18757,13 @@
               </a:defRPr>
             </a:pPr>
             <a:r>
-              <a:t>Tesla Optimus: 공장 내 테스트 중이나 Musk 본인도 '아직 material usage 아님' 인정 — 2027 consumer 판매가 re-rating 트리거.</a:t>
+              <a:t>TSLA · 테슬라 Optimus: 공장 내 테스트 중이나 Musk 본인도 '아직 material usage 아님' 인정 — 2027 consumer 판매가 re-rating 트리거.</a:t>
             </a:r>
           </a:p>
           <a:p>
             <a:pPr>
               <a:lnSpc>
-                <a:spcPct val="115000"/>
+                <a:spcPct val="125000"/>
               </a:lnSpc>
               <a:spcAft>
                 <a:spcPts val="1000"/>
@@ -18445,13 +18775,13 @@
               </a:defRPr>
             </a:pPr>
             <a:r>
-              <a:t>Figure AI: 비상장, BotQ 공장 1대/시간 생산 — valuation $39B는 '기대'가 반영된 수치.</a:t>
+              <a:t>피겨 AI(비상장): 비상장, BotQ 공장 1대/시간 생산 — valuation $39B는 '기대'가 반영된 수치.</a:t>
             </a:r>
           </a:p>
           <a:p>
             <a:pPr>
               <a:lnSpc>
-                <a:spcPct val="115000"/>
+                <a:spcPct val="125000"/>
               </a:lnSpc>
               <a:spcAft>
                 <a:spcPts val="1000"/>
@@ -18912,7 +19242,7 @@
           <a:p>
             <a:pPr>
               <a:lnSpc>
-                <a:spcPct val="115000"/>
+                <a:spcPct val="125000"/>
               </a:lnSpc>
               <a:spcAft>
                 <a:spcPts val="1200"/>
@@ -18924,13 +19254,13 @@
               </a:defRPr>
             </a:pPr>
             <a:r>
-              <a:t>SpaceX가 Falcon 9 재사용으로 kg당 발사 비용을 10배 이상 낮췄습니다. '우주는 정부 전용'에서 '민간 인프라'로 바뀌는 전환점입니다.</a:t>
+              <a:t>SPCX · 스페이스X가 Falcon 9 재사용으로 kg당 발사 비용을 10배 이상 낮췄습니다. '우주는 정부 전용'에서 '민간 인프라'로 바뀌는 전환점입니다.</a:t>
             </a:r>
           </a:p>
           <a:p>
             <a:pPr>
               <a:lnSpc>
-                <a:spcPct val="115000"/>
+                <a:spcPct val="125000"/>
               </a:lnSpc>
               <a:spcAft>
                 <a:spcPts val="1200"/>
@@ -18942,13 +19272,13 @@
               </a:defRPr>
             </a:pPr>
             <a:r>
-              <a:t>2026년 SpaceX 상장(SPCX)은 우주 경제에 '가격 표'가 생긴 것 — 다른 우주주는 SpaceX 대비 할인·프리미엄으로 거래됩니다.</a:t>
+              <a:t>2026년 SPCX · 스페이스X 상장(SPCX(스페이스X))은 우주 경제에 '가격 표'가 생긴 것 — 다른 우주주는 SPCX · 스페이스X 대비 할인·프리미엄으로 거래됩니다.</a:t>
             </a:r>
           </a:p>
           <a:p>
             <a:pPr>
               <a:lnSpc>
-                <a:spcPct val="115000"/>
+                <a:spcPct val="125000"/>
               </a:lnSpc>
               <a:spcAft>
                 <a:spcPts val="1200"/>
@@ -18966,7 +19296,7 @@
           <a:p>
             <a:pPr>
               <a:lnSpc>
-                <a:spcPct val="115000"/>
+                <a:spcPct val="125000"/>
               </a:lnSpc>
               <a:spcAft>
                 <a:spcPts val="1200"/>
@@ -18978,7 +19308,7 @@
               </a:defRPr>
             </a:pPr>
             <a:r>
-              <a:t>Rocket Lab(RKLB): 미국 2위 발사, Neutron으로 중형 시장 진입 시도 — SpaceX 다음으로 순수 플레이에 가까움.</a:t>
+              <a:t>RKLB · 로켓랩(RKLB(로켓랩)): 미국 2위 발사, Neutron으로 중형 시장 진입 시도 — SPCX · 스페이스X 다음으로 순수 플레이에 가까움.</a:t>
             </a:r>
           </a:p>
         </p:txBody>
@@ -19314,14 +19644,22 @@
           <a:lstStyle/>
           <a:p>
             <a:pPr>
-              <a:defRPr sz="1400" b="1">
+              <a:defRPr sz="900" b="0">
                 <a:solidFill>
                   <a:srgbClr val="0F172A"/>
                 </a:solidFill>
               </a:defRPr>
             </a:pPr>
             <a:r>
-              <a:t>SPCX RKLB FLY</a:t>
+              <a:t>SPCX · 스페이스X</a:t>
+            </a:r>
+            <a:br/>
+            <a:r>
+              <a:t>RKLB · 로켓랩</a:t>
+            </a:r>
+            <a:br/>
+            <a:r>
+              <a:t>FLY · 파이어플라이</a:t>
             </a:r>
           </a:p>
           <a:p>
@@ -19484,14 +19822,22 @@
           <a:lstStyle/>
           <a:p>
             <a:pPr>
-              <a:defRPr sz="1400" b="1">
+              <a:defRPr sz="900" b="0">
                 <a:solidFill>
                   <a:srgbClr val="0F172A"/>
                 </a:solidFill>
               </a:defRPr>
             </a:pPr>
             <a:r>
-              <a:t>ASTS IRDM GSAT</a:t>
+              <a:t>ASTS · AST 스페이스모바일</a:t>
+            </a:r>
+            <a:br/>
+            <a:r>
+              <a:t>IRDM · 이리듐</a:t>
+            </a:r>
+            <a:br/>
+            <a:r>
+              <a:t>GSAT · 글로벌스타</a:t>
             </a:r>
           </a:p>
           <a:p>
@@ -19654,14 +20000,18 @@
           <a:lstStyle/>
           <a:p>
             <a:pPr>
-              <a:defRPr sz="1400" b="1">
+              <a:defRPr sz="900" b="0">
                 <a:solidFill>
                   <a:srgbClr val="0F172A"/>
                 </a:solidFill>
               </a:defRPr>
             </a:pPr>
             <a:r>
-              <a:t>PL BKSY</a:t>
+              <a:t>PL · 플래닛랩스</a:t>
+            </a:r>
+            <a:br/>
+            <a:r>
+              <a:t>BKSY · 블랙스카이</a:t>
             </a:r>
           </a:p>
           <a:p>
@@ -19824,14 +20174,26 @@
           <a:lstStyle/>
           <a:p>
             <a:pPr>
-              <a:defRPr sz="1400" b="1">
+              <a:defRPr sz="900" b="0">
                 <a:solidFill>
                   <a:srgbClr val="0F172A"/>
                 </a:solidFill>
               </a:defRPr>
             </a:pPr>
             <a:r>
-              <a:t>LMT NOC RTX LHX</a:t>
+              <a:t>LMT · 록히드마틴</a:t>
+            </a:r>
+            <a:br/>
+            <a:r>
+              <a:t>NOC · 노스롭 그루먼</a:t>
+            </a:r>
+            <a:br/>
+            <a:r>
+              <a:t>RTX · RTX</a:t>
+            </a:r>
+            <a:br/>
+            <a:r>
+              <a:t>LHX · L3해리스</a:t>
             </a:r>
           </a:p>
           <a:p>
@@ -20292,7 +20654,7 @@
           <a:p>
             <a:pPr>
               <a:lnSpc>
-                <a:spcPct val="115000"/>
+                <a:spcPct val="125000"/>
               </a:lnSpc>
               <a:spcAft>
                 <a:spcPts val="1200"/>
@@ -20310,7 +20672,7 @@
           <a:p>
             <a:pPr>
               <a:lnSpc>
-                <a:spcPct val="115000"/>
+                <a:spcPct val="125000"/>
               </a:lnSpc>
               <a:spcAft>
                 <a:spcPts val="1200"/>
@@ -20328,7 +20690,7 @@
           <a:p>
             <a:pPr>
               <a:lnSpc>
-                <a:spcPct val="115000"/>
+                <a:spcPct val="125000"/>
               </a:lnSpc>
               <a:spcAft>
                 <a:spcPts val="1200"/>
@@ -20340,13 +20702,13 @@
               </a:defRPr>
             </a:pPr>
             <a:r>
-              <a:t>출처: Morgan Stanley Big Picture 2026, McKinsey/Gartner Tech Trends, CHIPS Act 공식 문서, Morningstar, IonQ IR, Goldman Sachs AI Capex 리포트 등.</a:t>
+              <a:t>출처: Morgan Stanley Big Picture 2026, McKinsey/Gartner Tech Trends, CHIPS Act 공식 문서, Morningstar, IONQ · 아이온큐 IR, Goldman Sachs AI Capex 리포트 등.</a:t>
             </a:r>
           </a:p>
           <a:p>
             <a:pPr>
               <a:lnSpc>
-                <a:spcPct val="115000"/>
+                <a:spcPct val="125000"/>
               </a:lnSpc>
               <a:spcAft>
                 <a:spcPts val="1200"/>
@@ -20572,7 +20934,7 @@
           <a:p>
             <a:pPr>
               <a:lnSpc>
-                <a:spcPct val="115000"/>
+                <a:spcPct val="125000"/>
               </a:lnSpc>
               <a:spcAft>
                 <a:spcPts val="1200"/>
@@ -20590,7 +20952,7 @@
           <a:p>
             <a:pPr>
               <a:lnSpc>
-                <a:spcPct val="115000"/>
+                <a:spcPct val="125000"/>
               </a:lnSpc>
               <a:spcAft>
                 <a:spcPts val="1200"/>
@@ -20608,7 +20970,7 @@
           <a:p>
             <a:pPr>
               <a:lnSpc>
-                <a:spcPct val="115000"/>
+                <a:spcPct val="125000"/>
               </a:lnSpc>
               <a:spcAft>
                 <a:spcPts val="1200"/>
@@ -20620,13 +20982,13 @@
               </a:defRPr>
             </a:pPr>
             <a:r>
-              <a:t>LLY 62% + NVO 31% = 사실상 duopoly. 신규 진입자(AMGN, VKTX)는 '더 나은 효능·oral·근육 보존'으로 틈새를 노림.</a:t>
+              <a:t>LLY(일라이 릴리) 62% + NVO(노보 노디스크) 31% = 사실상 duopoly. 신규 진입자(AMGN(암젠), VKTX(바이킹))는 '더 나은 효능·oral·근육 보존'으로 틈새를 노림.</a:t>
             </a:r>
           </a:p>
           <a:p>
             <a:pPr>
               <a:lnSpc>
-                <a:spcPct val="115000"/>
+                <a:spcPct val="125000"/>
               </a:lnSpc>
               <a:spcAft>
                 <a:spcPts val="1200"/>
@@ -20976,7 +21338,7 @@
               </a:defRPr>
             </a:pPr>
             <a:r>
-              <a:t>투자: LLY/NVO=core · AMGN/VKTX=optionality · TMO/DHR=피킹스앤샤벨</a:t>
+              <a:t>투자: LLY(일라이 릴리)/NVO(노보 노디스크)=core · AMGN(암젠)/VKTX(바이킹)=optionality · TMO(써모피셔)/DHR(다나허)=피킹스앤샤벨</a:t>
             </a:r>
           </a:p>
         </p:txBody>
@@ -20998,7 +21360,7 @@
         <p:spPr>
           <a:xfrm>
             <a:off x="457200" y="2011680"/>
-            <a:ext cx="4114800" cy="4176427"/>
+            <a:ext cx="4114800" cy="4181244"/>
           </a:xfrm>
           <a:prstGeom prst="rect">
             <a:avLst/>
@@ -21028,8 +21390,11 @@
           <a:lstStyle/>
           <a:p>
             <a:pPr>
+              <a:lnSpc>
+                <a:spcPct val="120000"/>
+              </a:lnSpc>
               <a:spcAft>
-                <a:spcPts val="800"/>
+                <a:spcPts val="1000"/>
               </a:spcAft>
               <a:defRPr sz="1100">
                 <a:solidFill>
@@ -21038,13 +21403,16 @@
               </a:defRPr>
             </a:pPr>
             <a:r>
-              <a:t>▸  LLY: Mounjaro/Zepbound + orforglipron(oral) + retatrutide(triple)</a:t>
-            </a:r>
-          </a:p>
-          <a:p>
-            <a:pPr>
+              <a:t>•  LLY(일라이 릴리): Mounjaro/Zepbound + orforglipron(oral) + retatrutide(triple)</a:t>
+            </a:r>
+          </a:p>
+          <a:p>
+            <a:pPr>
+              <a:lnSpc>
+                <a:spcPct val="120000"/>
+              </a:lnSpc>
               <a:spcAft>
-                <a:spcPts val="800"/>
+                <a:spcPts val="1000"/>
               </a:spcAft>
               <a:defRPr sz="1100">
                 <a:solidFill>
@@ -21053,13 +21421,16 @@
               </a:defRPr>
             </a:pPr>
             <a:r>
-              <a:t>▸  NVO: Ozempic/Wegovy + CagriSema(amylin combo)</a:t>
-            </a:r>
-          </a:p>
-          <a:p>
-            <a:pPr>
+              <a:t>•  NVO(노보 노디스크): Ozempic/Wegovy + CagriSema(amylin combo)</a:t>
+            </a:r>
+          </a:p>
+          <a:p>
+            <a:pPr>
+              <a:lnSpc>
+                <a:spcPct val="120000"/>
+              </a:lnSpc>
               <a:spcAft>
-                <a:spcPts val="800"/>
+                <a:spcPts val="1000"/>
               </a:spcAft>
               <a:defRPr sz="1100">
                 <a:solidFill>
@@ -21068,13 +21439,16 @@
               </a:defRPr>
             </a:pPr>
             <a:r>
-              <a:t>▸  다음 승자 조건: (1) oral 순응도 (2) 근손실 적음 (3) 심장·간 데이터</a:t>
-            </a:r>
-          </a:p>
-          <a:p>
-            <a:pPr>
+              <a:t>•  다음 승자 조건: (1) oral 순응도 (2) 근손실 적음 (3) 심장·간 데이터</a:t>
+            </a:r>
+          </a:p>
+          <a:p>
+            <a:pPr>
+              <a:lnSpc>
+                <a:spcPct val="120000"/>
+              </a:lnSpc>
               <a:spcAft>
-                <a:spcPts val="800"/>
+                <a:spcPts val="1000"/>
               </a:spcAft>
               <a:defRPr sz="1100">
                 <a:solidFill>
@@ -21083,7 +21457,7 @@
               </a:defRPr>
             </a:pPr>
             <a:r>
-              <a:t>▸  공급: 2026부터 점진적 완화, but 여전히 병목 구간</a:t>
+              <a:t>•  공급: 2026부터 점진적 완화, but 여전히 병목 구간</a:t>
             </a:r>
           </a:p>
         </p:txBody>
@@ -21532,7 +21906,7 @@
           <a:p>
             <a:pPr>
               <a:lnSpc>
-                <a:spcPct val="115000"/>
+                <a:spcPct val="125000"/>
               </a:lnSpc>
               <a:spcAft>
                 <a:spcPts val="1200"/>
@@ -21550,7 +21924,7 @@
           <a:p>
             <a:pPr>
               <a:lnSpc>
-                <a:spcPct val="115000"/>
+                <a:spcPct val="125000"/>
               </a:lnSpc>
               <a:spcAft>
                 <a:spcPts val="1200"/>
@@ -21562,13 +21936,13 @@
               </a:defRPr>
             </a:pPr>
             <a:r>
-              <a:t>희토류: NdFeB 자석은 EV·풍력·미사일·AI 서버에 필수. 중국이 정제의 대부분을 장악 → MP Materials가 미국 유일 통합 체인.</a:t>
+              <a:t>희토류: NdFeB 자석은 EV·풍력·미사일·AI 서버에 필수. 중국이 정제의 대부분을 장악 → MP(MP 머티리얼즈) Materials가 미국 유일 통합 체인.</a:t>
             </a:r>
           </a:p>
           <a:p>
             <a:pPr>
               <a:lnSpc>
-                <a:spcPct val="115000"/>
+                <a:spcPct val="125000"/>
               </a:lnSpc>
               <a:spcAft>
                 <a:spcPts val="1200"/>
@@ -21580,13 +21954,13 @@
               </a:defRPr>
             </a:pPr>
             <a:r>
-              <a:t>구리: 전력망·DC·EV 모두 구리 소비 증가. FCX 등 미국/칠레 광산.</a:t>
+              <a:t>구리: 전력망·DC·EV 모두 구리 소비 증가. FCX(프리포트 맥모란) 등 미국/칠레 광산.</a:t>
             </a:r>
           </a:p>
           <a:p>
             <a:pPr>
               <a:lnSpc>
-                <a:spcPct val="115000"/>
+                <a:spcPct val="125000"/>
               </a:lnSpc>
               <a:spcAft>
                 <a:spcPts val="1200"/>
@@ -21598,13 +21972,13 @@
               </a:defRPr>
             </a:pPr>
             <a:r>
-              <a:t>방산: 우크라·중동·대만 긴장으로 예산 구조적 증가. LMT·NOC·RTX.</a:t>
+              <a:t>방산: 우크라·중동·대만 긴장으로 예산 구조적 증가. LMT(록히드마틴)·NOC(노스롭 그루먼)·RTX(RTX).</a:t>
             </a:r>
           </a:p>
           <a:p>
             <a:pPr>
               <a:lnSpc>
-                <a:spcPct val="115000"/>
+                <a:spcPct val="125000"/>
               </a:lnSpc>
               <a:spcAft>
                 <a:spcPts val="1200"/>
@@ -21616,7 +21990,7 @@
               </a:defRPr>
             </a:pPr>
             <a:r>
-              <a:t>사이버: PQC 마이그레이션 + AI 공격 증가 → CRWD·PANW.</a:t>
+              <a:t>사이버: PQC 마이그레이션 + AI 공격 증가 → CRWD(크라우드스트라이크)·PANW(팔로알토).</a:t>
             </a:r>
           </a:p>
         </p:txBody>
@@ -22370,7 +22744,7 @@
           <a:p>
             <a:pPr>
               <a:lnSpc>
-                <a:spcPct val="115000"/>
+                <a:spcPct val="125000"/>
               </a:lnSpc>
               <a:spcAft>
                 <a:spcPts val="1000"/>
@@ -22382,13 +22756,13 @@
               </a:defRPr>
             </a:pPr>
             <a:r>
-              <a:t>MP Materials: DoD 15% 지분 + NdPr $110/kg 10년 floor → 중국 수출 중단 후 미국 내 magnet 생산(2025.12~).</a:t>
+              <a:t>MP(MP 머티리얼즈) Materials: DoD 15% 지분 + NdPr $110/kg 10년 floor → 중국 수출 중단 후 미국 내 magnet 생산(2025.12~).</a:t>
             </a:r>
           </a:p>
           <a:p>
             <a:pPr>
               <a:lnSpc>
-                <a:spcPct val="115000"/>
+                <a:spcPct val="125000"/>
               </a:lnSpc>
               <a:spcAft>
                 <a:spcPts val="1000"/>
@@ -22400,13 +22774,13 @@
               </a:defRPr>
             </a:pPr>
             <a:r>
-              <a:t>PLTR: 정부·군 AI 소프트웨어 — '실적 모멘텀 + 정책' 겹침.</a:t>
+              <a:t>PLTR(팔란티어): 정부·군 AI 소프트웨어 — '실적 모멘텀 + 정책' 겹침.</a:t>
             </a:r>
           </a:p>
           <a:p>
             <a:pPr>
               <a:lnSpc>
-                <a:spcPct val="115000"/>
+                <a:spcPct val="125000"/>
               </a:lnSpc>
               <a:spcAft>
                 <a:spcPts val="1000"/>
@@ -23215,7 +23589,7 @@
         </p:nvGraphicFramePr>
         <p:xfrm>
           <a:off x="365760" y="1188720"/>
-          <a:ext cx="6858000" cy="1353312"/>
+          <a:ext cx="7040880" cy="1545336"/>
         </p:xfrm>
         <a:graphic>
           <a:graphicData uri="http://schemas.openxmlformats.org/drawingml/2006/table">
@@ -23224,19 +23598,19 @@
                 <a:tableStyleId>{5C22544A-7EE6-4342-B048-85BDC9FD1C3A}</a:tableStyleId>
               </a:tblPr>
               <a:tblGrid>
-                <a:gridCol w="914400"/>
-                <a:gridCol w="2560320"/>
-                <a:gridCol w="2286000"/>
-                <a:gridCol w="1097280"/>
+                <a:gridCol w="822960"/>
+                <a:gridCol w="2926080"/>
+                <a:gridCol w="2103120"/>
+                <a:gridCol w="1188720"/>
               </a:tblGrid>
-              <a:tr h="338328">
+              <a:tr h="386334">
                 <a:tc>
                   <a:txBody>
                     <a:bodyPr/>
                     <a:lstStyle/>
                     <a:p>
                       <a:pPr>
-                        <a:defRPr b="1" sz="900">
+                        <a:defRPr b="1" sz="1100">
                           <a:solidFill>
                             <a:srgbClr val="FFFFFF"/>
                           </a:solidFill>
@@ -23259,7 +23633,7 @@
                     <a:lstStyle/>
                     <a:p>
                       <a:pPr>
-                        <a:defRPr b="1" sz="900">
+                        <a:defRPr b="1" sz="1100">
                           <a:solidFill>
                             <a:srgbClr val="FFFFFF"/>
                           </a:solidFill>
@@ -23282,7 +23656,7 @@
                     <a:lstStyle/>
                     <a:p>
                       <a:pPr>
-                        <a:defRPr b="1" sz="900">
+                        <a:defRPr b="1" sz="1100">
                           <a:solidFill>
                             <a:srgbClr val="FFFFFF"/>
                           </a:solidFill>
@@ -23305,7 +23679,7 @@
                     <a:lstStyle/>
                     <a:p>
                       <a:pPr>
-                        <a:defRPr b="1" sz="900">
+                        <a:defRPr b="1" sz="1100">
                           <a:solidFill>
                             <a:srgbClr val="FFFFFF"/>
                           </a:solidFill>
@@ -23323,14 +23697,14 @@
                   </a:tcPr>
                 </a:tc>
               </a:tr>
-              <a:tr h="338328">
+              <a:tr h="386334">
                 <a:tc>
                   <a:txBody>
                     <a:bodyPr/>
                     <a:lstStyle/>
                     <a:p>
                       <a:pPr>
-                        <a:defRPr sz="800">
+                        <a:defRPr sz="1000">
                           <a:solidFill>
                             <a:srgbClr val="334155"/>
                           </a:solidFill>
@@ -23341,7 +23715,7 @@
                       </a:r>
                     </a:p>
                   </a:txBody>
-                  <a:tcPr>
+                  <a:tcPr marL="54864" marR="36576" marT="36576" marB="36576">
                     <a:solidFill>
                       <a:srgbClr val="F8FAFC"/>
                     </a:solidFill>
@@ -23353,18 +23727,66 @@
                     <a:lstStyle/>
                     <a:p>
                       <a:pPr>
-                        <a:defRPr sz="800">
+                        <a:defRPr sz="1000">
                           <a:solidFill>
                             <a:srgbClr val="334155"/>
                           </a:solidFill>
                         </a:defRPr>
                       </a:pPr>
                       <a:r>
-                        <a:t>VRT ETN CEG LLY AMAT</a:t>
+                        <a:t>VRT(버티브) · 버티브</a:t>
+                      </a:r>
+                    </a:p>
+                    <a:p>
+                      <a:pPr>
+                        <a:defRPr sz="1000">
+                          <a:solidFill>
+                            <a:srgbClr val="334155"/>
+                          </a:solidFill>
+                        </a:defRPr>
+                      </a:pPr>
+                      <a:r>
+                        <a:t>ETN(이튼) · 이튼</a:t>
+                      </a:r>
+                    </a:p>
+                    <a:p>
+                      <a:pPr>
+                        <a:defRPr sz="1000">
+                          <a:solidFill>
+                            <a:srgbClr val="334155"/>
+                          </a:solidFill>
+                        </a:defRPr>
+                      </a:pPr>
+                      <a:r>
+                        <a:t>CEG(컨스텔레이션 에너지) · 컨스텔레이션 에너지</a:t>
+                      </a:r>
+                    </a:p>
+                    <a:p>
+                      <a:pPr>
+                        <a:defRPr sz="1000">
+                          <a:solidFill>
+                            <a:srgbClr val="334155"/>
+                          </a:solidFill>
+                        </a:defRPr>
+                      </a:pPr>
+                      <a:r>
+                        <a:t>LLY(일라이 릴리) · 일라이 릴리</a:t>
+                      </a:r>
+                    </a:p>
+                    <a:p>
+                      <a:pPr>
+                        <a:defRPr sz="1000">
+                          <a:solidFill>
+                            <a:srgbClr val="334155"/>
+                          </a:solidFill>
+                        </a:defRPr>
+                      </a:pPr>
+                      <a:r>
+                        <a:t>AMAT(어플라이드 머티리얼즈) · 어플라이드 머티리얼즈</a:t>
                       </a:r>
                     </a:p>
                   </a:txBody>
-                  <a:tcPr>
+                  <a:tcPr marL="54864" marR="36576" marT="36576" marB="36576">
                     <a:solidFill>
                       <a:srgbClr val="F8FAFC"/>
                     </a:solidFill>
@@ -23376,7 +23798,7 @@
                     <a:lstStyle/>
                     <a:p>
                       <a:pPr>
-                        <a:defRPr sz="800">
+                        <a:defRPr sz="1000">
                           <a:solidFill>
                             <a:srgbClr val="334155"/>
                           </a:solidFill>
@@ -23387,7 +23809,7 @@
                       </a:r>
                     </a:p>
                   </a:txBody>
-                  <a:tcPr>
+                  <a:tcPr marL="54864" marR="36576" marT="36576" marB="36576">
                     <a:solidFill>
                       <a:srgbClr val="F8FAFC"/>
                     </a:solidFill>
@@ -23399,32 +23821,32 @@
                     <a:lstStyle/>
                     <a:p>
                       <a:pPr>
-                        <a:defRPr sz="800">
+                        <a:defRPr sz="1000">
                           <a:solidFill>
                             <a:srgbClr val="334155"/>
                           </a:solidFill>
                         </a:defRPr>
                       </a:pPr>
                       <a:r>
-                        <a:t>SOXX NUKZ</a:t>
+                        <a:t>SOXX(반도체 ETF) · NUKZ(원자력 ETF)</a:t>
                       </a:r>
                     </a:p>
                   </a:txBody>
-                  <a:tcPr>
+                  <a:tcPr marL="54864" marR="36576" marT="36576" marB="36576">
                     <a:solidFill>
                       <a:srgbClr val="F8FAFC"/>
                     </a:solidFill>
                   </a:tcPr>
                 </a:tc>
               </a:tr>
-              <a:tr h="338328">
+              <a:tr h="386334">
                 <a:tc>
                   <a:txBody>
                     <a:bodyPr/>
                     <a:lstStyle/>
                     <a:p>
                       <a:pPr>
-                        <a:defRPr sz="800">
+                        <a:defRPr sz="1000">
                           <a:solidFill>
                             <a:srgbClr val="334155"/>
                           </a:solidFill>
@@ -23435,7 +23857,7 @@
                       </a:r>
                     </a:p>
                   </a:txBody>
-                  <a:tcPr>
+                  <a:tcPr marL="54864" marR="36576" marT="36576" marB="36576">
                     <a:solidFill>
                       <a:srgbClr val="FFFFFF"/>
                     </a:solidFill>
@@ -23447,18 +23869,54 @@
                     <a:lstStyle/>
                     <a:p>
                       <a:pPr>
-                        <a:defRPr sz="800">
+                        <a:defRPr sz="1000">
                           <a:solidFill>
                             <a:srgbClr val="334155"/>
                           </a:solidFill>
                         </a:defRPr>
                       </a:pPr>
                       <a:r>
-                        <a:t>OKLO IONQ RKLB TSLA</a:t>
+                        <a:t>OKLO(오클로) · 오클로</a:t>
+                      </a:r>
+                    </a:p>
+                    <a:p>
+                      <a:pPr>
+                        <a:defRPr sz="1000">
+                          <a:solidFill>
+                            <a:srgbClr val="334155"/>
+                          </a:solidFill>
+                        </a:defRPr>
+                      </a:pPr>
+                      <a:r>
+                        <a:t>IONQ(아이온큐) · 아이온큐</a:t>
+                      </a:r>
+                    </a:p>
+                    <a:p>
+                      <a:pPr>
+                        <a:defRPr sz="1000">
+                          <a:solidFill>
+                            <a:srgbClr val="334155"/>
+                          </a:solidFill>
+                        </a:defRPr>
+                      </a:pPr>
+                      <a:r>
+                        <a:t>RKLB(로켓랩) · 로켓랩</a:t>
+                      </a:r>
+                    </a:p>
+                    <a:p>
+                      <a:pPr>
+                        <a:defRPr sz="1000">
+                          <a:solidFill>
+                            <a:srgbClr val="334155"/>
+                          </a:solidFill>
+                        </a:defRPr>
+                      </a:pPr>
+                      <a:r>
+                        <a:t>TSLA(테슬라) · 테슬라</a:t>
                       </a:r>
                     </a:p>
                   </a:txBody>
-                  <a:tcPr>
+                  <a:tcPr marL="54864" marR="36576" marT="36576" marB="36576">
                     <a:solidFill>
                       <a:srgbClr val="FFFFFF"/>
                     </a:solidFill>
@@ -23470,7 +23928,7 @@
                     <a:lstStyle/>
                     <a:p>
                       <a:pPr>
-                        <a:defRPr sz="800">
+                        <a:defRPr sz="1000">
                           <a:solidFill>
                             <a:srgbClr val="334155"/>
                           </a:solidFill>
@@ -23481,7 +23939,7 @@
                       </a:r>
                     </a:p>
                   </a:txBody>
-                  <a:tcPr>
+                  <a:tcPr marL="54864" marR="36576" marT="36576" marB="36576">
                     <a:solidFill>
                       <a:srgbClr val="FFFFFF"/>
                     </a:solidFill>
@@ -23493,32 +23951,32 @@
                     <a:lstStyle/>
                     <a:p>
                       <a:pPr>
-                        <a:defRPr sz="800">
+                        <a:defRPr sz="1000">
                           <a:solidFill>
                             <a:srgbClr val="334155"/>
                           </a:solidFill>
                         </a:defRPr>
                       </a:pPr>
                       <a:r>
-                        <a:t>ARKX BOTZ</a:t>
+                        <a:t>ARKX(우주 ETF) · BOTZ(로봇 ETF)</a:t>
                       </a:r>
                     </a:p>
                   </a:txBody>
-                  <a:tcPr>
+                  <a:tcPr marL="54864" marR="36576" marT="36576" marB="36576">
                     <a:solidFill>
                       <a:srgbClr val="FFFFFF"/>
                     </a:solidFill>
                   </a:tcPr>
                 </a:tc>
               </a:tr>
-              <a:tr h="338328">
+              <a:tr h="386334">
                 <a:tc>
                   <a:txBody>
                     <a:bodyPr/>
                     <a:lstStyle/>
                     <a:p>
                       <a:pPr>
-                        <a:defRPr sz="800">
+                        <a:defRPr sz="1000">
                           <a:solidFill>
                             <a:srgbClr val="334155"/>
                           </a:solidFill>
@@ -23529,7 +23987,7 @@
                       </a:r>
                     </a:p>
                   </a:txBody>
-                  <a:tcPr>
+                  <a:tcPr marL="54864" marR="36576" marT="36576" marB="36576">
                     <a:solidFill>
                       <a:srgbClr val="F8FAFC"/>
                     </a:solidFill>
@@ -23541,18 +23999,18 @@
                     <a:lstStyle/>
                     <a:p>
                       <a:pPr>
-                        <a:defRPr sz="800">
+                        <a:defRPr sz="1000">
                           <a:solidFill>
                             <a:srgbClr val="334155"/>
                           </a:solidFill>
                         </a:defRPr>
                       </a:pPr>
                       <a:r>
-                        <a:t>PQC·Gene edit·Lunar</a:t>
+                        <a:t>PQC · 유전자편집 · 달 탐사</a:t>
                       </a:r>
                     </a:p>
                   </a:txBody>
-                  <a:tcPr>
+                  <a:tcPr marL="54864" marR="36576" marT="36576" marB="36576">
                     <a:solidFill>
                       <a:srgbClr val="F8FAFC"/>
                     </a:solidFill>
@@ -23564,7 +24022,7 @@
                     <a:lstStyle/>
                     <a:p>
                       <a:pPr>
-                        <a:defRPr sz="800">
+                        <a:defRPr sz="1000">
                           <a:solidFill>
                             <a:srgbClr val="334155"/>
                           </a:solidFill>
@@ -23575,7 +24033,7 @@
                       </a:r>
                     </a:p>
                   </a:txBody>
-                  <a:tcPr>
+                  <a:tcPr marL="54864" marR="36576" marT="36576" marB="36576">
                     <a:solidFill>
                       <a:srgbClr val="F8FAFC"/>
                     </a:solidFill>
@@ -23587,18 +24045,18 @@
                     <a:lstStyle/>
                     <a:p>
                       <a:pPr>
-                        <a:defRPr sz="800">
+                        <a:defRPr sz="1000">
                           <a:solidFill>
                             <a:srgbClr val="334155"/>
                           </a:solidFill>
                         </a:defRPr>
                       </a:pPr>
                       <a:r>
-                        <a:t>HACK XBI</a:t>
+                        <a:t>HACK(사이버 ETF) · XBI(바이오 ETF)</a:t>
                       </a:r>
                     </a:p>
                   </a:txBody>
-                  <a:tcPr>
+                  <a:tcPr marL="54864" marR="36576" marT="36576" marB="36576">
                     <a:solidFill>
                       <a:srgbClr val="F8FAFC"/>
                     </a:solidFill>
@@ -23757,7 +24215,7 @@
               </a:defRPr>
             </a:pPr>
             <a:r>
-              <a:t>□ 실행 리스크: SMR·휴머노이드·양자는 '연기'가 일상적</a:t>
+              <a:t>□ 실행 리스크: SMR(뉴스케일)·휴머노이드·양자는 '연기'가 일상적</a:t>
             </a:r>
           </a:p>
           <a:p>
@@ -24001,7 +24459,7 @@
           <a:p>
             <a:pPr>
               <a:lnSpc>
-                <a:spcPct val="115000"/>
+                <a:spcPct val="125000"/>
               </a:lnSpc>
               <a:spcAft>
                 <a:spcPts val="1200"/>
@@ -24013,13 +24471,13 @@
               </a:defRPr>
             </a:pPr>
             <a:r>
-              <a:t>2026–30년 주식시장의 중심축은 'AI가 만든 전기·실물·안보 수요'입니다. GPU 한 종목이 아니라, 전기를 공급하고(CEG), 식히고(VRT), 반도체를 만들고(AMAT), 약을 팔고(LLY) 하는 회사들이 같이 움직입니다.</a:t>
+              <a:t>2026–30년 주식시장의 중심축은 'AI가 만든 전기·실물·안보 수요'입니다. GPU 한 종목이 아니라, 전기를 공급하고(CEG(컨스텔레이션 에너지)), 식히고(VRT(버티브)), 반도체를 만들고(AMAT(어플라이드 머티리얼즈)), 약을 팔고(LLY(일라이 릴리)) 하는 회사들이 같이 움직입니다.</a:t>
             </a:r>
           </a:p>
           <a:p>
             <a:pPr>
               <a:lnSpc>
-                <a:spcPct val="115000"/>
+                <a:spcPct val="125000"/>
               </a:lnSpc>
               <a:spcAft>
                 <a:spcPts val="1200"/>
@@ -24037,7 +24495,7 @@
           <a:p>
             <a:pPr>
               <a:lnSpc>
-                <a:spcPct val="115000"/>
+                <a:spcPct val="125000"/>
               </a:lnSpc>
               <a:spcAft>
                 <a:spcPts val="1200"/>
@@ -24049,13 +24507,13 @@
               </a:defRPr>
             </a:pPr>
             <a:r>
-              <a:t>3–5년 후 본격화: SMR 가동, FTQC, 휴머노이드 B2B, 우주 Neutron.</a:t>
+              <a:t>3–5년 후 본격화: SMR(뉴스케일) 가동, FTQC, 휴머노이드 B2B, 우주 Neutron.</a:t>
             </a:r>
           </a:p>
           <a:p>
             <a:pPr>
               <a:lnSpc>
-                <a:spcPct val="115000"/>
+                <a:spcPct val="125000"/>
               </a:lnSpc>
               <a:spcAft>
                 <a:spcPts val="1200"/>
@@ -24073,7 +24531,7 @@
           <a:p>
             <a:pPr>
               <a:lnSpc>
-                <a:spcPct val="115000"/>
+                <a:spcPct val="125000"/>
               </a:lnSpc>
               <a:spcAft>
                 <a:spcPts val="1200"/>
@@ -25025,7 +25483,7 @@
           <a:p>
             <a:pPr>
               <a:lnSpc>
-                <a:spcPct val="115000"/>
+                <a:spcPct val="125000"/>
               </a:lnSpc>
               <a:spcAft>
                 <a:spcPts val="1000"/>
@@ -25037,13 +25495,13 @@
               </a:defRPr>
             </a:pPr>
             <a:r>
-              <a:t>2023–25년 주식시장은 'AI = Nvidia·Microsoft 등 소수 메가캡'으로 수익이 집중됐습니다. 2026년부터 Morgan Stanley가 말하는 Great Broadening(수익의 대확산)이 시작됩니다.</a:t>
+              <a:t>2023–25년 주식시장은 'AI = NVDA · 엔비디아·MSFT · 마이크로소프트 등 소수 메가캡'으로 수익이 집중됐습니다. 2026년부터 Morgan Stanley가 말하는 Great Broadening(수익의 대확산)이 시작됩니다.</a:t>
             </a:r>
           </a:p>
           <a:p>
             <a:pPr>
               <a:lnSpc>
-                <a:spcPct val="115000"/>
+                <a:spcPct val="125000"/>
               </a:lnSpc>
               <a:spcAft>
                 <a:spcPts val="1000"/>
@@ -25061,7 +25519,7 @@
           <a:p>
             <a:pPr>
               <a:lnSpc>
-                <a:spcPct val="115000"/>
+                <a:spcPct val="125000"/>
               </a:lnSpc>
               <a:spcAft>
                 <a:spcPts val="1000"/>
@@ -25522,7 +25980,7 @@
           <a:p>
             <a:pPr>
               <a:lnSpc>
-                <a:spcPct val="115000"/>
+                <a:spcPct val="125000"/>
               </a:lnSpc>
               <a:spcAft>
                 <a:spcPts val="1200"/>
@@ -25540,7 +25998,7 @@
           <a:p>
             <a:pPr>
               <a:lnSpc>
-                <a:spcPct val="115000"/>
+                <a:spcPct val="125000"/>
               </a:lnSpc>
               <a:spcAft>
                 <a:spcPts val="1200"/>
@@ -25558,7 +26016,7 @@
           <a:p>
             <a:pPr>
               <a:lnSpc>
-                <a:spcPct val="115000"/>
+                <a:spcPct val="125000"/>
               </a:lnSpc>
               <a:spcAft>
                 <a:spcPts val="1200"/>
@@ -25576,7 +26034,7 @@
           <a:p>
             <a:pPr>
               <a:lnSpc>
-                <a:spcPct val="115000"/>
+                <a:spcPct val="125000"/>
               </a:lnSpc>
               <a:spcAft>
                 <a:spcPts val="1200"/>
@@ -26318,7 +26776,7 @@
               </a:defRPr>
             </a:pPr>
             <a:r>
-              <a:t>그래서 Vertiv(냉각)·Eaton(변압기)·Caterpillar(건설)가 NVDA와 같이 또는 더 오른 것</a:t>
+              <a:t>그래서 VRT · 버티브(냉각)·ETN · 이튼(변압기)·CAT · 캐터필러(건설)가 NVDA와 같이 또는 더 오른 것</a:t>
             </a:r>
           </a:p>
         </p:txBody>
@@ -26370,8 +26828,11 @@
           <a:lstStyle/>
           <a:p>
             <a:pPr>
+              <a:lnSpc>
+                <a:spcPct val="120000"/>
+              </a:lnSpc>
               <a:spcAft>
-                <a:spcPts val="800"/>
+                <a:spcPts val="1000"/>
               </a:spcAft>
               <a:defRPr sz="1100">
                 <a:solidFill>
@@ -26380,13 +26841,16 @@
               </a:defRPr>
             </a:pPr>
             <a:r>
-              <a:t>▸  Vertiv: 백로그 $15B, 주문이 출하의 2.9배 → 2027년까지 매출 가시성</a:t>
-            </a:r>
-          </a:p>
-          <a:p>
-            <a:pPr>
+              <a:t>•  VRT · 버티브: 백로그 $15B, 주문이 출하의 2.9배 → 2027년까지 매출 가시성</a:t>
+            </a:r>
+          </a:p>
+          <a:p>
+            <a:pPr>
+              <a:lnSpc>
+                <a:spcPct val="120000"/>
+              </a:lnSpc>
               <a:spcAft>
-                <a:spcPts val="800"/>
+                <a:spcPts val="1000"/>
               </a:spcAft>
               <a:defRPr sz="1100">
                 <a:solidFill>
@@ -26395,13 +26859,16 @@
               </a:defRPr>
             </a:pPr>
             <a:r>
-              <a:t>▸  변압기·스위치기어 납기 최대 5년 → 공급 부족 = 가격 결정력</a:t>
-            </a:r>
-          </a:p>
-          <a:p>
-            <a:pPr>
+              <a:t>•  변압기·스위치기어 납기 최대 5년 → 공급 부족 = 가격 결정력</a:t>
+            </a:r>
+          </a:p>
+          <a:p>
+            <a:pPr>
+              <a:lnSpc>
+                <a:spcPct val="120000"/>
+              </a:lnSpc>
               <a:spcAft>
-                <a:spcPts val="800"/>
+                <a:spcPts val="1000"/>
               </a:spcAft>
               <a:defRPr sz="1100">
                 <a:solidFill>
@@ -26410,13 +26877,16 @@
               </a:defRPr>
             </a:pPr>
             <a:r>
-              <a:t>▸  투자자 관점: 'AI 테마주'가 아닌 '산업 장비주'로 보는 것이 정확</a:t>
-            </a:r>
-          </a:p>
-          <a:p>
-            <a:pPr>
+              <a:t>•  투자자 관점: 'AI 테마주'가 아닌 '산업 장비주'로 보는 것이 정확</a:t>
+            </a:r>
+          </a:p>
+          <a:p>
+            <a:pPr>
+              <a:lnSpc>
+                <a:spcPct val="120000"/>
+              </a:lnSpc>
               <a:spcAft>
-                <a:spcPts val="800"/>
+                <a:spcPts val="1000"/>
               </a:spcAft>
               <a:defRPr sz="1100">
                 <a:solidFill>
@@ -26425,7 +26895,7 @@
               </a:defRPr>
             </a:pPr>
             <a:r>
-              <a:t>▸  리스크: DC 건설 지연 시 단기 주가 조정, but 백로그는 오히려 늘어남</a:t>
+              <a:t>•  리스크: DC 건설 지연 시 단기 주가 조정, but 백로그는 오히려 늘어남</a:t>
             </a:r>
           </a:p>
         </p:txBody>

</xml_diff>